<commit_message>
minor modification for lesson 1
</commit_message>
<xml_diff>
--- a/theory_01-course_introduction/theory_1-course_introduction.pptx
+++ b/theory_01-course_introduction/theory_1-course_introduction.pptx
@@ -5,7 +5,7 @@
     <p:sldMasterId id="2147483648" r:id="rId1"/>
   </p:sldMasterIdLst>
   <p:notesMasterIdLst>
-    <p:notesMasterId r:id="rId51"/>
+    <p:notesMasterId r:id="rId50"/>
   </p:notesMasterIdLst>
   <p:sldIdLst>
     <p:sldId id="256" r:id="rId2"/>
@@ -27,36 +27,35 @@
     <p:sldId id="264" r:id="rId18"/>
     <p:sldId id="273" r:id="rId19"/>
     <p:sldId id="280" r:id="rId20"/>
-    <p:sldId id="274" r:id="rId21"/>
-    <p:sldId id="275" r:id="rId22"/>
-    <p:sldId id="277" r:id="rId23"/>
-    <p:sldId id="282" r:id="rId24"/>
-    <p:sldId id="283" r:id="rId25"/>
-    <p:sldId id="285" r:id="rId26"/>
-    <p:sldId id="284" r:id="rId27"/>
-    <p:sldId id="265" r:id="rId28"/>
-    <p:sldId id="407" r:id="rId29"/>
-    <p:sldId id="406" r:id="rId30"/>
-    <p:sldId id="395" r:id="rId31"/>
-    <p:sldId id="267" r:id="rId32"/>
-    <p:sldId id="408" r:id="rId33"/>
-    <p:sldId id="290" r:id="rId34"/>
-    <p:sldId id="291" r:id="rId35"/>
-    <p:sldId id="292" r:id="rId36"/>
-    <p:sldId id="393" r:id="rId37"/>
-    <p:sldId id="394" r:id="rId38"/>
-    <p:sldId id="396" r:id="rId39"/>
-    <p:sldId id="398" r:id="rId40"/>
-    <p:sldId id="289" r:id="rId41"/>
-    <p:sldId id="287" r:id="rId42"/>
-    <p:sldId id="405" r:id="rId43"/>
-    <p:sldId id="397" r:id="rId44"/>
-    <p:sldId id="399" r:id="rId45"/>
-    <p:sldId id="400" r:id="rId46"/>
-    <p:sldId id="401" r:id="rId47"/>
-    <p:sldId id="404" r:id="rId48"/>
-    <p:sldId id="402" r:id="rId49"/>
-    <p:sldId id="403" r:id="rId50"/>
+    <p:sldId id="275" r:id="rId21"/>
+    <p:sldId id="277" r:id="rId22"/>
+    <p:sldId id="282" r:id="rId23"/>
+    <p:sldId id="283" r:id="rId24"/>
+    <p:sldId id="285" r:id="rId25"/>
+    <p:sldId id="284" r:id="rId26"/>
+    <p:sldId id="265" r:id="rId27"/>
+    <p:sldId id="407" r:id="rId28"/>
+    <p:sldId id="406" r:id="rId29"/>
+    <p:sldId id="395" r:id="rId30"/>
+    <p:sldId id="267" r:id="rId31"/>
+    <p:sldId id="408" r:id="rId32"/>
+    <p:sldId id="290" r:id="rId33"/>
+    <p:sldId id="291" r:id="rId34"/>
+    <p:sldId id="292" r:id="rId35"/>
+    <p:sldId id="393" r:id="rId36"/>
+    <p:sldId id="394" r:id="rId37"/>
+    <p:sldId id="396" r:id="rId38"/>
+    <p:sldId id="398" r:id="rId39"/>
+    <p:sldId id="289" r:id="rId40"/>
+    <p:sldId id="287" r:id="rId41"/>
+    <p:sldId id="405" r:id="rId42"/>
+    <p:sldId id="397" r:id="rId43"/>
+    <p:sldId id="399" r:id="rId44"/>
+    <p:sldId id="400" r:id="rId45"/>
+    <p:sldId id="401" r:id="rId46"/>
+    <p:sldId id="404" r:id="rId47"/>
+    <p:sldId id="402" r:id="rId48"/>
+    <p:sldId id="403" r:id="rId49"/>
   </p:sldIdLst>
   <p:sldSz cx="12192000" cy="6858000"/>
   <p:notesSz cx="6858000" cy="9144000"/>
@@ -1027,7 +1026,7 @@
           <a:p>
             <a:fld id="{60DFD464-F8EE-42BA-9BEF-F6DE8365F087}" type="datetimeFigureOut">
               <a:rPr lang="en-GB" smtClean="0"/>
-              <a:t>24/02/2025</a:t>
+              <a:t>25/02/2025</a:t>
             </a:fld>
             <a:endParaRPr lang="en-GB"/>
           </a:p>
@@ -1444,7 +1443,7 @@
           <a:p>
             <a:fld id="{CC0F43FB-3F33-3F4B-9768-2FBED988F992}" type="slidenum">
               <a:rPr lang="en-IT" smtClean="0"/>
-              <a:t>37</a:t>
+              <a:t>36</a:t>
             </a:fld>
             <a:endParaRPr lang="en-IT"/>
           </a:p>
@@ -1528,7 +1527,7 @@
           <a:p>
             <a:fld id="{CC0F43FB-3F33-3F4B-9768-2FBED988F992}" type="slidenum">
               <a:rPr lang="en-IT" smtClean="0"/>
-              <a:t>38</a:t>
+              <a:t>37</a:t>
             </a:fld>
             <a:endParaRPr lang="en-IT"/>
           </a:p>
@@ -1612,7 +1611,7 @@
           <a:p>
             <a:fld id="{CC0F43FB-3F33-3F4B-9768-2FBED988F992}" type="slidenum">
               <a:rPr lang="en-IT" smtClean="0"/>
-              <a:t>39</a:t>
+              <a:t>38</a:t>
             </a:fld>
             <a:endParaRPr lang="en-IT"/>
           </a:p>
@@ -1720,7 +1719,7 @@
           <a:p>
             <a:fld id="{CC0F43FB-3F33-3F4B-9768-2FBED988F992}" type="slidenum">
               <a:rPr lang="en-IT" smtClean="0"/>
-              <a:t>43</a:t>
+              <a:t>42</a:t>
             </a:fld>
             <a:endParaRPr lang="en-IT"/>
           </a:p>
@@ -1828,7 +1827,7 @@
           <a:p>
             <a:fld id="{CC0F43FB-3F33-3F4B-9768-2FBED988F992}" type="slidenum">
               <a:rPr lang="en-IT" smtClean="0"/>
-              <a:t>44</a:t>
+              <a:t>43</a:t>
             </a:fld>
             <a:endParaRPr lang="en-IT"/>
           </a:p>
@@ -1936,7 +1935,7 @@
           <a:p>
             <a:fld id="{CC0F43FB-3F33-3F4B-9768-2FBED988F992}" type="slidenum">
               <a:rPr lang="en-IT" smtClean="0"/>
-              <a:t>45</a:t>
+              <a:t>44</a:t>
             </a:fld>
             <a:endParaRPr lang="en-IT"/>
           </a:p>
@@ -2044,7 +2043,7 @@
           <a:p>
             <a:fld id="{CC0F43FB-3F33-3F4B-9768-2FBED988F992}" type="slidenum">
               <a:rPr lang="en-IT" smtClean="0"/>
-              <a:t>46</a:t>
+              <a:t>45</a:t>
             </a:fld>
             <a:endParaRPr lang="en-IT"/>
           </a:p>
@@ -2152,7 +2151,7 @@
           <a:p>
             <a:fld id="{CC0F43FB-3F33-3F4B-9768-2FBED988F992}" type="slidenum">
               <a:rPr lang="en-IT" smtClean="0"/>
-              <a:t>47</a:t>
+              <a:t>46</a:t>
             </a:fld>
             <a:endParaRPr lang="en-IT"/>
           </a:p>
@@ -2260,7 +2259,7 @@
           <a:p>
             <a:fld id="{CC0F43FB-3F33-3F4B-9768-2FBED988F992}" type="slidenum">
               <a:rPr lang="en-IT" smtClean="0"/>
-              <a:t>48</a:t>
+              <a:t>47</a:t>
             </a:fld>
             <a:endParaRPr lang="en-IT"/>
           </a:p>
@@ -2368,7 +2367,7 @@
           <a:p>
             <a:fld id="{CC0F43FB-3F33-3F4B-9768-2FBED988F992}" type="slidenum">
               <a:rPr lang="en-IT" smtClean="0"/>
-              <a:t>49</a:t>
+              <a:t>48</a:t>
             </a:fld>
             <a:endParaRPr lang="en-IT"/>
           </a:p>
@@ -2452,7 +2451,7 @@
           <a:p>
             <a:fld id="{338E2716-4F7E-4141-A218-58474614BAF2}" type="slidenum">
               <a:rPr lang="en-GB" smtClean="0"/>
-              <a:t>26</a:t>
+              <a:t>25</a:t>
             </a:fld>
             <a:endParaRPr lang="en-GB"/>
           </a:p>
@@ -2536,7 +2535,7 @@
           <a:p>
             <a:fld id="{338E2716-4F7E-4141-A218-58474614BAF2}" type="slidenum">
               <a:rPr lang="en-GB" smtClean="0"/>
-              <a:t>27</a:t>
+              <a:t>26</a:t>
             </a:fld>
             <a:endParaRPr lang="en-GB"/>
           </a:p>
@@ -2620,7 +2619,7 @@
           <a:p>
             <a:fld id="{338E2716-4F7E-4141-A218-58474614BAF2}" type="slidenum">
               <a:rPr lang="en-GB" smtClean="0"/>
-              <a:t>29</a:t>
+              <a:t>28</a:t>
             </a:fld>
             <a:endParaRPr lang="en-GB"/>
           </a:p>
@@ -2728,7 +2727,7 @@
           <a:p>
             <a:fld id="{338E2716-4F7E-4141-A218-58474614BAF2}" type="slidenum">
               <a:rPr lang="en-GB" smtClean="0"/>
-              <a:t>30</a:t>
+              <a:t>29</a:t>
             </a:fld>
             <a:endParaRPr lang="en-GB"/>
           </a:p>
@@ -2812,7 +2811,7 @@
           <a:p>
             <a:fld id="{CC0F43FB-3F33-3F4B-9768-2FBED988F992}" type="slidenum">
               <a:rPr lang="en-IT" smtClean="0"/>
-              <a:t>33</a:t>
+              <a:t>32</a:t>
             </a:fld>
             <a:endParaRPr lang="en-IT"/>
           </a:p>
@@ -2896,7 +2895,7 @@
           <a:p>
             <a:fld id="{CC0F43FB-3F33-3F4B-9768-2FBED988F992}" type="slidenum">
               <a:rPr lang="en-IT" smtClean="0"/>
-              <a:t>34</a:t>
+              <a:t>33</a:t>
             </a:fld>
             <a:endParaRPr lang="en-IT"/>
           </a:p>
@@ -2980,7 +2979,7 @@
           <a:p>
             <a:fld id="{CC0F43FB-3F33-3F4B-9768-2FBED988F992}" type="slidenum">
               <a:rPr lang="en-IT" smtClean="0"/>
-              <a:t>35</a:t>
+              <a:t>34</a:t>
             </a:fld>
             <a:endParaRPr lang="en-IT"/>
           </a:p>
@@ -3064,7 +3063,7 @@
           <a:p>
             <a:fld id="{CC0F43FB-3F33-3F4B-9768-2FBED988F992}" type="slidenum">
               <a:rPr lang="en-IT" smtClean="0"/>
-              <a:t>36</a:t>
+              <a:t>35</a:t>
             </a:fld>
             <a:endParaRPr lang="en-IT"/>
           </a:p>
@@ -8611,56 +8610,6 @@
       </p:pic>
       <p:sp>
         <p:nvSpPr>
-          <p:cNvPr id="3" name="Freccia a destra 2"/>
-          <p:cNvSpPr/>
-          <p:nvPr/>
-        </p:nvSpPr>
-        <p:spPr>
-          <a:xfrm>
-            <a:off x="3471918" y="5520707"/>
-            <a:ext cx="1028700" cy="391982"/>
-          </a:xfrm>
-          <a:prstGeom prst="rightArrow">
-            <a:avLst/>
-          </a:prstGeom>
-          <a:solidFill>
-            <a:schemeClr val="tx1"/>
-          </a:solidFill>
-          <a:ln>
-            <a:solidFill>
-              <a:schemeClr val="tx1"/>
-            </a:solidFill>
-          </a:ln>
-        </p:spPr>
-        <p:style>
-          <a:lnRef idx="2">
-            <a:schemeClr val="accent1">
-              <a:shade val="50000"/>
-            </a:schemeClr>
-          </a:lnRef>
-          <a:fillRef idx="1">
-            <a:schemeClr val="accent1"/>
-          </a:fillRef>
-          <a:effectRef idx="0">
-            <a:schemeClr val="accent1"/>
-          </a:effectRef>
-          <a:fontRef idx="minor">
-            <a:schemeClr val="lt1"/>
-          </a:fontRef>
-        </p:style>
-        <p:txBody>
-          <a:bodyPr rtlCol="0" anchor="ctr"/>
-          <a:lstStyle/>
-          <a:p>
-            <a:pPr algn="ctr"/>
-            <a:endParaRPr lang="en-GB">
-              <a:latin typeface="Aptos" panose="020B0004020202020204" pitchFamily="34" charset="0"/>
-            </a:endParaRPr>
-          </a:p>
-        </p:txBody>
-      </p:sp>
-      <p:sp>
-        <p:nvSpPr>
           <p:cNvPr id="15" name="CasellaDiTesto 14"/>
           <p:cNvSpPr txBox="1"/>
           <p:nvPr/>
@@ -8761,6 +8710,54 @@
               <a:t>14</a:t>
             </a:fld>
             <a:endParaRPr lang="en-GB"/>
+          </a:p>
+        </p:txBody>
+      </p:sp>
+      <p:sp>
+        <p:nvSpPr>
+          <p:cNvPr id="13" name="Freccia bidirezionale orizzontale 9">
+            <a:extLst>
+              <a:ext uri="{FF2B5EF4-FFF2-40B4-BE49-F238E27FC236}">
+                <a16:creationId xmlns:a16="http://schemas.microsoft.com/office/drawing/2014/main" id="{069BCFC6-1A04-8AB0-138F-32E64868B15E}"/>
+              </a:ext>
+            </a:extLst>
+          </p:cNvPr>
+          <p:cNvSpPr/>
+          <p:nvPr/>
+        </p:nvSpPr>
+        <p:spPr>
+          <a:xfrm>
+            <a:off x="3361043" y="5567796"/>
+            <a:ext cx="1566825" cy="379817"/>
+          </a:xfrm>
+          <a:prstGeom prst="leftRightArrow">
+            <a:avLst/>
+          </a:prstGeom>
+        </p:spPr>
+        <p:style>
+          <a:lnRef idx="2">
+            <a:schemeClr val="dk1">
+              <a:shade val="50000"/>
+            </a:schemeClr>
+          </a:lnRef>
+          <a:fillRef idx="1">
+            <a:schemeClr val="dk1"/>
+          </a:fillRef>
+          <a:effectRef idx="0">
+            <a:schemeClr val="dk1"/>
+          </a:effectRef>
+          <a:fontRef idx="minor">
+            <a:schemeClr val="lt1"/>
+          </a:fontRef>
+        </p:style>
+        <p:txBody>
+          <a:bodyPr rtlCol="0" anchor="ctr"/>
+          <a:lstStyle/>
+          <a:p>
+            <a:pPr algn="ctr"/>
+            <a:endParaRPr lang="en-GB">
+              <a:latin typeface="Aptos" panose="020B0004020202020204" pitchFamily="34" charset="0"/>
+            </a:endParaRPr>
           </a:p>
         </p:txBody>
       </p:sp>
@@ -10462,779 +10459,6 @@
           <a:lstStyle/>
           <a:p>
             <a:r>
-              <a:rPr lang="en-US" dirty="0"/>
-              <a:t>Investigative monitoring for diagnostic purpose</a:t>
-            </a:r>
-          </a:p>
-        </p:txBody>
-      </p:sp>
-      <p:sp>
-        <p:nvSpPr>
-          <p:cNvPr id="3" name="Segnaposto contenuto 2"/>
-          <p:cNvSpPr>
-            <a:spLocks noGrp="1"/>
-          </p:cNvSpPr>
-          <p:nvPr>
-            <p:ph idx="1"/>
-          </p:nvPr>
-        </p:nvSpPr>
-        <p:spPr>
-          <a:xfrm>
-            <a:off x="428172" y="1361167"/>
-            <a:ext cx="11368314" cy="5113774"/>
-          </a:xfrm>
-        </p:spPr>
-        <p:txBody>
-          <a:bodyPr>
-            <a:normAutofit/>
-          </a:bodyPr>
-          <a:lstStyle/>
-          <a:p>
-            <a:r>
-              <a:rPr lang="en-US" dirty="0"/>
-              <a:t>Monitoring of health parameters in </a:t>
-            </a:r>
-            <a:r>
-              <a:rPr lang="en-US" b="1" dirty="0" err="1"/>
-              <a:t>outclinic</a:t>
-            </a:r>
-            <a:r>
-              <a:rPr lang="en-US" b="1" dirty="0"/>
-              <a:t> context</a:t>
-            </a:r>
-            <a:r>
-              <a:rPr lang="en-US" dirty="0"/>
-              <a:t>, for a limited period of time (e.g., few days) to </a:t>
-            </a:r>
-            <a:r>
-              <a:rPr lang="en-US" b="1" dirty="0"/>
-              <a:t>detect</a:t>
-            </a:r>
-            <a:r>
-              <a:rPr lang="en-US" dirty="0"/>
-              <a:t> a particular health condition that cannot be observed in clinic, to track the progress of a disease, or to </a:t>
-            </a:r>
-            <a:r>
-              <a:rPr lang="en-US" b="1" dirty="0"/>
-              <a:t>monitor</a:t>
-            </a:r>
-            <a:r>
-              <a:rPr lang="en-US" dirty="0"/>
-              <a:t> recovery from a specific health event. </a:t>
-            </a:r>
-          </a:p>
-          <a:p>
-            <a:endParaRPr lang="en-US" dirty="0"/>
-          </a:p>
-          <a:p>
-            <a:r>
-              <a:rPr lang="en-US" dirty="0"/>
-              <a:t>Examples:</a:t>
-            </a:r>
-          </a:p>
-          <a:p>
-            <a:pPr lvl="1"/>
-            <a:r>
-              <a:rPr lang="en-US" b="1" dirty="0"/>
-              <a:t>Professional CGM sensor</a:t>
-            </a:r>
-            <a:r>
-              <a:rPr lang="en-US" dirty="0"/>
-              <a:t>: CGM provided to the patient for a short period (e.g., 7 days). Based on the collected data the doctor can adjust/optimize the patient’s therapy.</a:t>
-            </a:r>
-          </a:p>
-          <a:p>
-            <a:pPr lvl="1"/>
-            <a:r>
-              <a:rPr lang="en-US" b="1" dirty="0"/>
-              <a:t>Holter and extended-</a:t>
-            </a:r>
-            <a:r>
-              <a:rPr lang="en-US" b="1" dirty="0" err="1"/>
-              <a:t>holter</a:t>
-            </a:r>
-            <a:r>
-              <a:rPr lang="en-US" b="1" dirty="0"/>
-              <a:t> systems</a:t>
-            </a:r>
-            <a:r>
-              <a:rPr lang="en-US" dirty="0"/>
-              <a:t>: monitor HR for limited periods (e.g., 1-7 days) for detection of heart issues, e.g., cardiac arrhythmias</a:t>
-            </a:r>
-          </a:p>
-          <a:p>
-            <a:pPr lvl="1"/>
-            <a:r>
-              <a:rPr lang="en-US" b="1" dirty="0"/>
-              <a:t>At-home sleep test </a:t>
-            </a:r>
-            <a:r>
-              <a:rPr lang="en-US" dirty="0"/>
-              <a:t>for the diagnosis of obstructive sleep apnea (stops in breathing during sleep): monitoring of sleep at home for at least 1 night using wearable sensors provided by the doctor (breathing sensor, effort belt, pulse oximeter, and microphone)</a:t>
-            </a:r>
-          </a:p>
-          <a:p>
-            <a:endParaRPr lang="it-IT" dirty="0"/>
-          </a:p>
-          <a:p>
-            <a:endParaRPr lang="it-IT" dirty="0"/>
-          </a:p>
-        </p:txBody>
-      </p:sp>
-      <p:sp>
-        <p:nvSpPr>
-          <p:cNvPr id="4" name="Segnaposto contenuto 2"/>
-          <p:cNvSpPr txBox="1">
-            <a:spLocks/>
-          </p:cNvSpPr>
-          <p:nvPr/>
-        </p:nvSpPr>
-        <p:spPr>
-          <a:xfrm>
-            <a:off x="428172" y="3045806"/>
-            <a:ext cx="5511309" cy="2844248"/>
-          </a:xfrm>
-          <a:prstGeom prst="rect">
-            <a:avLst/>
-          </a:prstGeom>
-        </p:spPr>
-        <p:txBody>
-          <a:bodyPr vert="horz" lIns="91440" tIns="45720" rIns="91440" bIns="45720" rtlCol="0">
-            <a:normAutofit/>
-          </a:bodyPr>
-          <a:lstStyle>
-            <a:lvl1pPr marL="342900" indent="-342900" algn="l" defTabSz="914400" rtl="0" eaLnBrk="1" latinLnBrk="0" hangingPunct="1">
-              <a:lnSpc>
-                <a:spcPct val="90000"/>
-              </a:lnSpc>
-              <a:spcBef>
-                <a:spcPts val="1000"/>
-              </a:spcBef>
-              <a:buClr>
-                <a:srgbClr val="00B050"/>
-              </a:buClr>
-              <a:buFont typeface="Wingdings" panose="05000000000000000000" pitchFamily="2" charset="2"/>
-              <a:buChar char="Ø"/>
-              <a:defRPr sz="2400" kern="1200">
-                <a:solidFill>
-                  <a:schemeClr val="tx1"/>
-                </a:solidFill>
-                <a:latin typeface="Palatino Linotype" panose="02040502050505030304" pitchFamily="18" charset="0"/>
-                <a:ea typeface="+mn-ea"/>
-                <a:cs typeface="+mn-cs"/>
-              </a:defRPr>
-            </a:lvl1pPr>
-            <a:lvl2pPr marL="685800" indent="-228600" algn="l" defTabSz="914400" rtl="0" eaLnBrk="1" latinLnBrk="0" hangingPunct="1">
-              <a:lnSpc>
-                <a:spcPct val="90000"/>
-              </a:lnSpc>
-              <a:spcBef>
-                <a:spcPts val="500"/>
-              </a:spcBef>
-              <a:buClr>
-                <a:srgbClr val="00B050"/>
-              </a:buClr>
-              <a:buFont typeface="Wingdings" panose="05000000000000000000" pitchFamily="2" charset="2"/>
-              <a:buChar char="§"/>
-              <a:defRPr sz="2000" kern="1200">
-                <a:solidFill>
-                  <a:schemeClr val="tx1"/>
-                </a:solidFill>
-                <a:latin typeface="Palatino Linotype" panose="02040502050505030304" pitchFamily="18" charset="0"/>
-                <a:ea typeface="+mn-ea"/>
-                <a:cs typeface="+mn-cs"/>
-              </a:defRPr>
-            </a:lvl2pPr>
-            <a:lvl3pPr marL="1143000" indent="-228600" algn="l" defTabSz="914400" rtl="0" eaLnBrk="1" latinLnBrk="0" hangingPunct="1">
-              <a:lnSpc>
-                <a:spcPct val="90000"/>
-              </a:lnSpc>
-              <a:spcBef>
-                <a:spcPts val="500"/>
-              </a:spcBef>
-              <a:buClr>
-                <a:srgbClr val="00B050"/>
-              </a:buClr>
-              <a:buFont typeface="Arial" panose="020B0604020202020204" pitchFamily="34" charset="0"/>
-              <a:buChar char="•"/>
-              <a:defRPr sz="1800" kern="1200">
-                <a:solidFill>
-                  <a:schemeClr val="tx1"/>
-                </a:solidFill>
-                <a:latin typeface="Palatino Linotype" panose="02040502050505030304" pitchFamily="18" charset="0"/>
-                <a:ea typeface="+mn-ea"/>
-                <a:cs typeface="+mn-cs"/>
-              </a:defRPr>
-            </a:lvl3pPr>
-            <a:lvl4pPr marL="1600200" indent="-228600" algn="l" defTabSz="914400" rtl="0" eaLnBrk="1" latinLnBrk="0" hangingPunct="1">
-              <a:lnSpc>
-                <a:spcPct val="90000"/>
-              </a:lnSpc>
-              <a:spcBef>
-                <a:spcPts val="500"/>
-              </a:spcBef>
-              <a:buClr>
-                <a:srgbClr val="00B050"/>
-              </a:buClr>
-              <a:buFont typeface="Courier New" panose="02070309020205020404" pitchFamily="49" charset="0"/>
-              <a:buChar char="o"/>
-              <a:defRPr sz="1600" kern="1200">
-                <a:solidFill>
-                  <a:schemeClr val="tx1"/>
-                </a:solidFill>
-                <a:latin typeface="Palatino Linotype" panose="02040502050505030304" pitchFamily="18" charset="0"/>
-                <a:ea typeface="+mn-ea"/>
-                <a:cs typeface="+mn-cs"/>
-              </a:defRPr>
-            </a:lvl4pPr>
-            <a:lvl5pPr marL="2057400" indent="-228600" algn="l" defTabSz="914400" rtl="0" eaLnBrk="1" latinLnBrk="0" hangingPunct="1">
-              <a:lnSpc>
-                <a:spcPct val="90000"/>
-              </a:lnSpc>
-              <a:spcBef>
-                <a:spcPts val="500"/>
-              </a:spcBef>
-              <a:buClr>
-                <a:srgbClr val="00B050"/>
-              </a:buClr>
-              <a:buFont typeface="Times New Roman" panose="02020603050405020304" pitchFamily="18" charset="0"/>
-              <a:buChar char="̶"/>
-              <a:defRPr sz="1600" kern="1200">
-                <a:solidFill>
-                  <a:schemeClr val="tx1"/>
-                </a:solidFill>
-                <a:latin typeface="Palatino Linotype" panose="02040502050505030304" pitchFamily="18" charset="0"/>
-                <a:ea typeface="+mn-ea"/>
-                <a:cs typeface="+mn-cs"/>
-              </a:defRPr>
-            </a:lvl5pPr>
-            <a:lvl6pPr marL="2514600" indent="-228600" algn="l" defTabSz="914400" rtl="0" eaLnBrk="1" latinLnBrk="0" hangingPunct="1">
-              <a:lnSpc>
-                <a:spcPct val="90000"/>
-              </a:lnSpc>
-              <a:spcBef>
-                <a:spcPts val="500"/>
-              </a:spcBef>
-              <a:buFont typeface="Arial" panose="020B0604020202020204" pitchFamily="34" charset="0"/>
-              <a:buChar char="•"/>
-              <a:defRPr sz="1800" kern="1200">
-                <a:solidFill>
-                  <a:schemeClr val="tx1"/>
-                </a:solidFill>
-                <a:latin typeface="+mn-lt"/>
-                <a:ea typeface="+mn-ea"/>
-                <a:cs typeface="+mn-cs"/>
-              </a:defRPr>
-            </a:lvl6pPr>
-            <a:lvl7pPr marL="2971800" indent="-228600" algn="l" defTabSz="914400" rtl="0" eaLnBrk="1" latinLnBrk="0" hangingPunct="1">
-              <a:lnSpc>
-                <a:spcPct val="90000"/>
-              </a:lnSpc>
-              <a:spcBef>
-                <a:spcPts val="500"/>
-              </a:spcBef>
-              <a:buFont typeface="Arial" panose="020B0604020202020204" pitchFamily="34" charset="0"/>
-              <a:buChar char="•"/>
-              <a:defRPr sz="1800" kern="1200">
-                <a:solidFill>
-                  <a:schemeClr val="tx1"/>
-                </a:solidFill>
-                <a:latin typeface="+mn-lt"/>
-                <a:ea typeface="+mn-ea"/>
-                <a:cs typeface="+mn-cs"/>
-              </a:defRPr>
-            </a:lvl7pPr>
-            <a:lvl8pPr marL="3429000" indent="-228600" algn="l" defTabSz="914400" rtl="0" eaLnBrk="1" latinLnBrk="0" hangingPunct="1">
-              <a:lnSpc>
-                <a:spcPct val="90000"/>
-              </a:lnSpc>
-              <a:spcBef>
-                <a:spcPts val="500"/>
-              </a:spcBef>
-              <a:buFont typeface="Arial" panose="020B0604020202020204" pitchFamily="34" charset="0"/>
-              <a:buChar char="•"/>
-              <a:defRPr sz="1800" kern="1200">
-                <a:solidFill>
-                  <a:schemeClr val="tx1"/>
-                </a:solidFill>
-                <a:latin typeface="+mn-lt"/>
-                <a:ea typeface="+mn-ea"/>
-                <a:cs typeface="+mn-cs"/>
-              </a:defRPr>
-            </a:lvl8pPr>
-            <a:lvl9pPr marL="3886200" indent="-228600" algn="l" defTabSz="914400" rtl="0" eaLnBrk="1" latinLnBrk="0" hangingPunct="1">
-              <a:lnSpc>
-                <a:spcPct val="90000"/>
-              </a:lnSpc>
-              <a:spcBef>
-                <a:spcPts val="500"/>
-              </a:spcBef>
-              <a:buFont typeface="Arial" panose="020B0604020202020204" pitchFamily="34" charset="0"/>
-              <a:buChar char="•"/>
-              <a:defRPr sz="1800" kern="1200">
-                <a:solidFill>
-                  <a:schemeClr val="tx1"/>
-                </a:solidFill>
-                <a:latin typeface="+mn-lt"/>
-                <a:ea typeface="+mn-ea"/>
-                <a:cs typeface="+mn-cs"/>
-              </a:defRPr>
-            </a:lvl9pPr>
-          </a:lstStyle>
-          <a:p>
-            <a:endParaRPr lang="it-IT" dirty="0"/>
-          </a:p>
-          <a:p>
-            <a:endParaRPr lang="it-IT" dirty="0"/>
-          </a:p>
-        </p:txBody>
-      </p:sp>
-      <p:sp>
-        <p:nvSpPr>
-          <p:cNvPr id="5" name="Segnaposto contenuto 2"/>
-          <p:cNvSpPr txBox="1">
-            <a:spLocks/>
-          </p:cNvSpPr>
-          <p:nvPr/>
-        </p:nvSpPr>
-        <p:spPr>
-          <a:xfrm>
-            <a:off x="6404723" y="5337849"/>
-            <a:ext cx="5511309" cy="1550908"/>
-          </a:xfrm>
-          <a:prstGeom prst="rect">
-            <a:avLst/>
-          </a:prstGeom>
-        </p:spPr>
-        <p:txBody>
-          <a:bodyPr vert="horz" lIns="91440" tIns="45720" rIns="91440" bIns="45720" rtlCol="0">
-            <a:normAutofit/>
-          </a:bodyPr>
-          <a:lstStyle>
-            <a:lvl1pPr marL="342900" indent="-342900" algn="l" defTabSz="914400" rtl="0" eaLnBrk="1" latinLnBrk="0" hangingPunct="1">
-              <a:lnSpc>
-                <a:spcPct val="90000"/>
-              </a:lnSpc>
-              <a:spcBef>
-                <a:spcPts val="1000"/>
-              </a:spcBef>
-              <a:buClr>
-                <a:srgbClr val="00B050"/>
-              </a:buClr>
-              <a:buFont typeface="Wingdings" panose="05000000000000000000" pitchFamily="2" charset="2"/>
-              <a:buChar char="Ø"/>
-              <a:defRPr sz="2400" kern="1200">
-                <a:solidFill>
-                  <a:schemeClr val="tx1"/>
-                </a:solidFill>
-                <a:latin typeface="Palatino Linotype" panose="02040502050505030304" pitchFamily="18" charset="0"/>
-                <a:ea typeface="+mn-ea"/>
-                <a:cs typeface="+mn-cs"/>
-              </a:defRPr>
-            </a:lvl1pPr>
-            <a:lvl2pPr marL="685800" indent="-228600" algn="l" defTabSz="914400" rtl="0" eaLnBrk="1" latinLnBrk="0" hangingPunct="1">
-              <a:lnSpc>
-                <a:spcPct val="90000"/>
-              </a:lnSpc>
-              <a:spcBef>
-                <a:spcPts val="500"/>
-              </a:spcBef>
-              <a:buClr>
-                <a:srgbClr val="00B050"/>
-              </a:buClr>
-              <a:buFont typeface="Wingdings" panose="05000000000000000000" pitchFamily="2" charset="2"/>
-              <a:buChar char="§"/>
-              <a:defRPr sz="2000" kern="1200">
-                <a:solidFill>
-                  <a:schemeClr val="tx1"/>
-                </a:solidFill>
-                <a:latin typeface="Palatino Linotype" panose="02040502050505030304" pitchFamily="18" charset="0"/>
-                <a:ea typeface="+mn-ea"/>
-                <a:cs typeface="+mn-cs"/>
-              </a:defRPr>
-            </a:lvl2pPr>
-            <a:lvl3pPr marL="1143000" indent="-228600" algn="l" defTabSz="914400" rtl="0" eaLnBrk="1" latinLnBrk="0" hangingPunct="1">
-              <a:lnSpc>
-                <a:spcPct val="90000"/>
-              </a:lnSpc>
-              <a:spcBef>
-                <a:spcPts val="500"/>
-              </a:spcBef>
-              <a:buClr>
-                <a:srgbClr val="00B050"/>
-              </a:buClr>
-              <a:buFont typeface="Arial" panose="020B0604020202020204" pitchFamily="34" charset="0"/>
-              <a:buChar char="•"/>
-              <a:defRPr sz="1800" kern="1200">
-                <a:solidFill>
-                  <a:schemeClr val="tx1"/>
-                </a:solidFill>
-                <a:latin typeface="Palatino Linotype" panose="02040502050505030304" pitchFamily="18" charset="0"/>
-                <a:ea typeface="+mn-ea"/>
-                <a:cs typeface="+mn-cs"/>
-              </a:defRPr>
-            </a:lvl3pPr>
-            <a:lvl4pPr marL="1600200" indent="-228600" algn="l" defTabSz="914400" rtl="0" eaLnBrk="1" latinLnBrk="0" hangingPunct="1">
-              <a:lnSpc>
-                <a:spcPct val="90000"/>
-              </a:lnSpc>
-              <a:spcBef>
-                <a:spcPts val="500"/>
-              </a:spcBef>
-              <a:buClr>
-                <a:srgbClr val="00B050"/>
-              </a:buClr>
-              <a:buFont typeface="Courier New" panose="02070309020205020404" pitchFamily="49" charset="0"/>
-              <a:buChar char="o"/>
-              <a:defRPr sz="1600" kern="1200">
-                <a:solidFill>
-                  <a:schemeClr val="tx1"/>
-                </a:solidFill>
-                <a:latin typeface="Palatino Linotype" panose="02040502050505030304" pitchFamily="18" charset="0"/>
-                <a:ea typeface="+mn-ea"/>
-                <a:cs typeface="+mn-cs"/>
-              </a:defRPr>
-            </a:lvl4pPr>
-            <a:lvl5pPr marL="2057400" indent="-228600" algn="l" defTabSz="914400" rtl="0" eaLnBrk="1" latinLnBrk="0" hangingPunct="1">
-              <a:lnSpc>
-                <a:spcPct val="90000"/>
-              </a:lnSpc>
-              <a:spcBef>
-                <a:spcPts val="500"/>
-              </a:spcBef>
-              <a:buClr>
-                <a:srgbClr val="00B050"/>
-              </a:buClr>
-              <a:buFont typeface="Times New Roman" panose="02020603050405020304" pitchFamily="18" charset="0"/>
-              <a:buChar char="̶"/>
-              <a:defRPr sz="1600" kern="1200">
-                <a:solidFill>
-                  <a:schemeClr val="tx1"/>
-                </a:solidFill>
-                <a:latin typeface="Palatino Linotype" panose="02040502050505030304" pitchFamily="18" charset="0"/>
-                <a:ea typeface="+mn-ea"/>
-                <a:cs typeface="+mn-cs"/>
-              </a:defRPr>
-            </a:lvl5pPr>
-            <a:lvl6pPr marL="2514600" indent="-228600" algn="l" defTabSz="914400" rtl="0" eaLnBrk="1" latinLnBrk="0" hangingPunct="1">
-              <a:lnSpc>
-                <a:spcPct val="90000"/>
-              </a:lnSpc>
-              <a:spcBef>
-                <a:spcPts val="500"/>
-              </a:spcBef>
-              <a:buFont typeface="Arial" panose="020B0604020202020204" pitchFamily="34" charset="0"/>
-              <a:buChar char="•"/>
-              <a:defRPr sz="1800" kern="1200">
-                <a:solidFill>
-                  <a:schemeClr val="tx1"/>
-                </a:solidFill>
-                <a:latin typeface="+mn-lt"/>
-                <a:ea typeface="+mn-ea"/>
-                <a:cs typeface="+mn-cs"/>
-              </a:defRPr>
-            </a:lvl6pPr>
-            <a:lvl7pPr marL="2971800" indent="-228600" algn="l" defTabSz="914400" rtl="0" eaLnBrk="1" latinLnBrk="0" hangingPunct="1">
-              <a:lnSpc>
-                <a:spcPct val="90000"/>
-              </a:lnSpc>
-              <a:spcBef>
-                <a:spcPts val="500"/>
-              </a:spcBef>
-              <a:buFont typeface="Arial" panose="020B0604020202020204" pitchFamily="34" charset="0"/>
-              <a:buChar char="•"/>
-              <a:defRPr sz="1800" kern="1200">
-                <a:solidFill>
-                  <a:schemeClr val="tx1"/>
-                </a:solidFill>
-                <a:latin typeface="+mn-lt"/>
-                <a:ea typeface="+mn-ea"/>
-                <a:cs typeface="+mn-cs"/>
-              </a:defRPr>
-            </a:lvl7pPr>
-            <a:lvl8pPr marL="3429000" indent="-228600" algn="l" defTabSz="914400" rtl="0" eaLnBrk="1" latinLnBrk="0" hangingPunct="1">
-              <a:lnSpc>
-                <a:spcPct val="90000"/>
-              </a:lnSpc>
-              <a:spcBef>
-                <a:spcPts val="500"/>
-              </a:spcBef>
-              <a:buFont typeface="Arial" panose="020B0604020202020204" pitchFamily="34" charset="0"/>
-              <a:buChar char="•"/>
-              <a:defRPr sz="1800" kern="1200">
-                <a:solidFill>
-                  <a:schemeClr val="tx1"/>
-                </a:solidFill>
-                <a:latin typeface="+mn-lt"/>
-                <a:ea typeface="+mn-ea"/>
-                <a:cs typeface="+mn-cs"/>
-              </a:defRPr>
-            </a:lvl8pPr>
-            <a:lvl9pPr marL="3886200" indent="-228600" algn="l" defTabSz="914400" rtl="0" eaLnBrk="1" latinLnBrk="0" hangingPunct="1">
-              <a:lnSpc>
-                <a:spcPct val="90000"/>
-              </a:lnSpc>
-              <a:spcBef>
-                <a:spcPts val="500"/>
-              </a:spcBef>
-              <a:buFont typeface="Arial" panose="020B0604020202020204" pitchFamily="34" charset="0"/>
-              <a:buChar char="•"/>
-              <a:defRPr sz="1800" kern="1200">
-                <a:solidFill>
-                  <a:schemeClr val="tx1"/>
-                </a:solidFill>
-                <a:latin typeface="+mn-lt"/>
-                <a:ea typeface="+mn-ea"/>
-                <a:cs typeface="+mn-cs"/>
-              </a:defRPr>
-            </a:lvl9pPr>
-          </a:lstStyle>
-          <a:p>
-            <a:endParaRPr lang="it-IT" dirty="0"/>
-          </a:p>
-        </p:txBody>
-      </p:sp>
-      <p:sp>
-        <p:nvSpPr>
-          <p:cNvPr id="6" name="Segnaposto numero diapositiva 5"/>
-          <p:cNvSpPr>
-            <a:spLocks noGrp="1"/>
-          </p:cNvSpPr>
-          <p:nvPr>
-            <p:ph type="sldNum" sz="quarter" idx="12"/>
-          </p:nvPr>
-        </p:nvSpPr>
-        <p:spPr/>
-        <p:txBody>
-          <a:bodyPr/>
-          <a:lstStyle/>
-          <a:p>
-            <a:fld id="{31DE2C5B-556E-47B8-A792-024C2FCA4ACC}" type="slidenum">
-              <a:rPr lang="en-GB" smtClean="0"/>
-              <a:t>20</a:t>
-            </a:fld>
-            <a:endParaRPr lang="en-GB"/>
-          </a:p>
-        </p:txBody>
-      </p:sp>
-    </p:spTree>
-    <p:extLst>
-      <p:ext uri="{BB962C8B-B14F-4D97-AF65-F5344CB8AC3E}">
-        <p14:creationId xmlns:p14="http://schemas.microsoft.com/office/powerpoint/2010/main" val="1055666775"/>
-      </p:ext>
-    </p:extLst>
-  </p:cSld>
-  <p:clrMapOvr>
-    <a:masterClrMapping/>
-  </p:clrMapOvr>
-  <p:timing>
-    <p:tnLst>
-      <p:par>
-        <p:cTn id="1" dur="indefinite" restart="never" nodeType="tmRoot">
-          <p:childTnLst>
-            <p:seq concurrent="1" nextAc="seek">
-              <p:cTn id="2" dur="indefinite" nodeType="mainSeq">
-                <p:childTnLst>
-                  <p:par>
-                    <p:cTn id="3" fill="hold">
-                      <p:stCondLst>
-                        <p:cond delay="indefinite"/>
-                      </p:stCondLst>
-                      <p:childTnLst>
-                        <p:par>
-                          <p:cTn id="4" fill="hold">
-                            <p:stCondLst>
-                              <p:cond delay="0"/>
-                            </p:stCondLst>
-                            <p:childTnLst>
-                              <p:par>
-                                <p:cTn id="5" presetID="1" presetClass="entr" presetSubtype="0" fill="hold" nodeType="clickEffect">
-                                  <p:stCondLst>
-                                    <p:cond delay="0"/>
-                                  </p:stCondLst>
-                                  <p:childTnLst>
-                                    <p:set>
-                                      <p:cBhvr>
-                                        <p:cTn id="6" dur="1" fill="hold">
-                                          <p:stCondLst>
-                                            <p:cond delay="0"/>
-                                          </p:stCondLst>
-                                        </p:cTn>
-                                        <p:tgtEl>
-                                          <p:spTgt spid="3">
-                                            <p:txEl>
-                                              <p:pRg st="2" end="2"/>
-                                            </p:txEl>
-                                          </p:spTgt>
-                                        </p:tgtEl>
-                                        <p:attrNameLst>
-                                          <p:attrName>style.visibility</p:attrName>
-                                        </p:attrNameLst>
-                                      </p:cBhvr>
-                                      <p:to>
-                                        <p:strVal val="visible"/>
-                                      </p:to>
-                                    </p:set>
-                                  </p:childTnLst>
-                                </p:cTn>
-                              </p:par>
-                              <p:par>
-                                <p:cTn id="7" presetID="1" presetClass="entr" presetSubtype="0" fill="hold" nodeType="withEffect">
-                                  <p:stCondLst>
-                                    <p:cond delay="0"/>
-                                  </p:stCondLst>
-                                  <p:childTnLst>
-                                    <p:set>
-                                      <p:cBhvr>
-                                        <p:cTn id="8" dur="1" fill="hold">
-                                          <p:stCondLst>
-                                            <p:cond delay="0"/>
-                                          </p:stCondLst>
-                                        </p:cTn>
-                                        <p:tgtEl>
-                                          <p:spTgt spid="3">
-                                            <p:txEl>
-                                              <p:pRg st="3" end="3"/>
-                                            </p:txEl>
-                                          </p:spTgt>
-                                        </p:tgtEl>
-                                        <p:attrNameLst>
-                                          <p:attrName>style.visibility</p:attrName>
-                                        </p:attrNameLst>
-                                      </p:cBhvr>
-                                      <p:to>
-                                        <p:strVal val="visible"/>
-                                      </p:to>
-                                    </p:set>
-                                  </p:childTnLst>
-                                </p:cTn>
-                              </p:par>
-                              <p:par>
-                                <p:cTn id="9" presetID="1" presetClass="entr" presetSubtype="0" fill="hold" nodeType="withEffect">
-                                  <p:stCondLst>
-                                    <p:cond delay="0"/>
-                                  </p:stCondLst>
-                                  <p:childTnLst>
-                                    <p:set>
-                                      <p:cBhvr>
-                                        <p:cTn id="10" dur="1" fill="hold">
-                                          <p:stCondLst>
-                                            <p:cond delay="0"/>
-                                          </p:stCondLst>
-                                        </p:cTn>
-                                        <p:tgtEl>
-                                          <p:spTgt spid="3">
-                                            <p:txEl>
-                                              <p:pRg st="4" end="4"/>
-                                            </p:txEl>
-                                          </p:spTgt>
-                                        </p:tgtEl>
-                                        <p:attrNameLst>
-                                          <p:attrName>style.visibility</p:attrName>
-                                        </p:attrNameLst>
-                                      </p:cBhvr>
-                                      <p:to>
-                                        <p:strVal val="visible"/>
-                                      </p:to>
-                                    </p:set>
-                                  </p:childTnLst>
-                                </p:cTn>
-                              </p:par>
-                              <p:par>
-                                <p:cTn id="11" presetID="1" presetClass="entr" presetSubtype="0" fill="hold" nodeType="withEffect">
-                                  <p:stCondLst>
-                                    <p:cond delay="0"/>
-                                  </p:stCondLst>
-                                  <p:childTnLst>
-                                    <p:set>
-                                      <p:cBhvr>
-                                        <p:cTn id="12" dur="1" fill="hold">
-                                          <p:stCondLst>
-                                            <p:cond delay="0"/>
-                                          </p:stCondLst>
-                                        </p:cTn>
-                                        <p:tgtEl>
-                                          <p:spTgt spid="3">
-                                            <p:txEl>
-                                              <p:pRg st="5" end="5"/>
-                                            </p:txEl>
-                                          </p:spTgt>
-                                        </p:tgtEl>
-                                        <p:attrNameLst>
-                                          <p:attrName>style.visibility</p:attrName>
-                                        </p:attrNameLst>
-                                      </p:cBhvr>
-                                      <p:to>
-                                        <p:strVal val="visible"/>
-                                      </p:to>
-                                    </p:set>
-                                  </p:childTnLst>
-                                </p:cTn>
-                              </p:par>
-                            </p:childTnLst>
-                          </p:cTn>
-                        </p:par>
-                      </p:childTnLst>
-                    </p:cTn>
-                  </p:par>
-                </p:childTnLst>
-              </p:cTn>
-              <p:prevCondLst>
-                <p:cond evt="onPrev" delay="0">
-                  <p:tgtEl>
-                    <p:sldTgt/>
-                  </p:tgtEl>
-                </p:cond>
-              </p:prevCondLst>
-              <p:nextCondLst>
-                <p:cond evt="onNext" delay="0">
-                  <p:tgtEl>
-                    <p:sldTgt/>
-                  </p:tgtEl>
-                </p:cond>
-              </p:nextCondLst>
-            </p:seq>
-          </p:childTnLst>
-        </p:cTn>
-      </p:par>
-    </p:tnLst>
-  </p:timing>
-</p:sld>
-</file>
-
-<file path=ppt/slides/slide21.xml><?xml version="1.0" encoding="utf-8"?>
-<p:sld xmlns:a="http://schemas.openxmlformats.org/drawingml/2006/main" xmlns:r="http://schemas.openxmlformats.org/officeDocument/2006/relationships" xmlns:p="http://schemas.openxmlformats.org/presentationml/2006/main">
-  <p:cSld>
-    <p:spTree>
-      <p:nvGrpSpPr>
-        <p:cNvPr id="1" name=""/>
-        <p:cNvGrpSpPr/>
-        <p:nvPr/>
-      </p:nvGrpSpPr>
-      <p:grpSpPr>
-        <a:xfrm>
-          <a:off x="0" y="0"/>
-          <a:ext cx="0" cy="0"/>
-          <a:chOff x="0" y="0"/>
-          <a:chExt cx="0" cy="0"/>
-        </a:xfrm>
-      </p:grpSpPr>
-      <p:sp>
-        <p:nvSpPr>
-          <p:cNvPr id="2" name="Titolo 1"/>
-          <p:cNvSpPr>
-            <a:spLocks noGrp="1"/>
-          </p:cNvSpPr>
-          <p:nvPr>
-            <p:ph type="title"/>
-          </p:nvPr>
-        </p:nvSpPr>
-        <p:spPr/>
-        <p:txBody>
-          <a:bodyPr/>
-          <a:lstStyle/>
-          <a:p>
-            <a:r>
               <a:rPr lang="it-IT" dirty="0"/>
               <a:t>Sensor-</a:t>
             </a:r>
@@ -11447,7 +10671,7 @@
           <a:p>
             <a:fld id="{31DE2C5B-556E-47B8-A792-024C2FCA4ACC}" type="slidenum">
               <a:rPr lang="en-GB" smtClean="0"/>
-              <a:t>21</a:t>
+              <a:t>20</a:t>
             </a:fld>
             <a:endParaRPr lang="en-GB"/>
           </a:p>
@@ -11814,7 +11038,7 @@
 </p:sld>
 </file>
 
-<file path=ppt/slides/slide22.xml><?xml version="1.0" encoding="utf-8"?>
+<file path=ppt/slides/slide21.xml><?xml version="1.0" encoding="utf-8"?>
 <p:sld xmlns:a="http://schemas.openxmlformats.org/drawingml/2006/main" xmlns:r="http://schemas.openxmlformats.org/officeDocument/2006/relationships" xmlns:p="http://schemas.openxmlformats.org/presentationml/2006/main">
   <p:cSld>
     <p:spTree>
@@ -12042,7 +11266,7 @@
           <a:p>
             <a:fld id="{31DE2C5B-556E-47B8-A792-024C2FCA4ACC}" type="slidenum">
               <a:rPr lang="en-GB" smtClean="0"/>
-              <a:t>22</a:t>
+              <a:t>21</a:t>
             </a:fld>
             <a:endParaRPr lang="en-GB"/>
           </a:p>
@@ -12061,7 +11285,7 @@
 </p:sld>
 </file>
 
-<file path=ppt/slides/slide23.xml><?xml version="1.0" encoding="utf-8"?>
+<file path=ppt/slides/slide22.xml><?xml version="1.0" encoding="utf-8"?>
 <p:sld xmlns:a="http://schemas.openxmlformats.org/drawingml/2006/main" xmlns:r="http://schemas.openxmlformats.org/officeDocument/2006/relationships" xmlns:p="http://schemas.openxmlformats.org/presentationml/2006/main">
   <p:cSld>
     <p:spTree>
@@ -12392,7 +11616,7 @@
           <a:p>
             <a:fld id="{31DE2C5B-556E-47B8-A792-024C2FCA4ACC}" type="slidenum">
               <a:rPr lang="en-GB" smtClean="0"/>
-              <a:t>23</a:t>
+              <a:t>22</a:t>
             </a:fld>
             <a:endParaRPr lang="en-GB"/>
           </a:p>
@@ -12516,7 +11740,7 @@
 </p:sld>
 </file>
 
-<file path=ppt/slides/slide24.xml><?xml version="1.0" encoding="utf-8"?>
+<file path=ppt/slides/slide23.xml><?xml version="1.0" encoding="utf-8"?>
 <p:sld xmlns:a="http://schemas.openxmlformats.org/drawingml/2006/main" xmlns:r="http://schemas.openxmlformats.org/officeDocument/2006/relationships" xmlns:p="http://schemas.openxmlformats.org/presentationml/2006/main">
   <p:cSld>
     <p:spTree>
@@ -12760,7 +11984,7 @@
           <a:p>
             <a:fld id="{31DE2C5B-556E-47B8-A792-024C2FCA4ACC}" type="slidenum">
               <a:rPr lang="en-GB" smtClean="0"/>
-              <a:t>24</a:t>
+              <a:t>23</a:t>
             </a:fld>
             <a:endParaRPr lang="en-GB"/>
           </a:p>
@@ -12779,7 +12003,7 @@
 </p:sld>
 </file>
 
-<file path=ppt/slides/slide25.xml><?xml version="1.0" encoding="utf-8"?>
+<file path=ppt/slides/slide24.xml><?xml version="1.0" encoding="utf-8"?>
 <p:sld xmlns:a="http://schemas.openxmlformats.org/drawingml/2006/main" xmlns:r="http://schemas.openxmlformats.org/officeDocument/2006/relationships" xmlns:p="http://schemas.openxmlformats.org/presentationml/2006/main">
   <p:cSld>
     <p:spTree>
@@ -14523,7 +13747,7 @@
           <a:p>
             <a:fld id="{31DE2C5B-556E-47B8-A792-024C2FCA4ACC}" type="slidenum">
               <a:rPr lang="en-GB" smtClean="0"/>
-              <a:t>25</a:t>
+              <a:t>24</a:t>
             </a:fld>
             <a:endParaRPr lang="en-GB"/>
           </a:p>
@@ -14803,6 +14027,214 @@
 </p:sld>
 </file>
 
+<file path=ppt/slides/slide25.xml><?xml version="1.0" encoding="utf-8"?>
+<p:sld xmlns:a="http://schemas.openxmlformats.org/drawingml/2006/main" xmlns:r="http://schemas.openxmlformats.org/officeDocument/2006/relationships" xmlns:p="http://schemas.openxmlformats.org/presentationml/2006/main">
+  <p:cSld>
+    <p:spTree>
+      <p:nvGrpSpPr>
+        <p:cNvPr id="1" name=""/>
+        <p:cNvGrpSpPr/>
+        <p:nvPr/>
+      </p:nvGrpSpPr>
+      <p:grpSpPr>
+        <a:xfrm>
+          <a:off x="0" y="0"/>
+          <a:ext cx="0" cy="0"/>
+          <a:chOff x="0" y="0"/>
+          <a:chExt cx="0" cy="0"/>
+        </a:xfrm>
+      </p:grpSpPr>
+      <p:sp>
+        <p:nvSpPr>
+          <p:cNvPr id="5" name="Titolo 4"/>
+          <p:cNvSpPr>
+            <a:spLocks noGrp="1"/>
+          </p:cNvSpPr>
+          <p:nvPr>
+            <p:ph type="title"/>
+          </p:nvPr>
+        </p:nvSpPr>
+        <p:spPr/>
+        <p:txBody>
+          <a:bodyPr/>
+          <a:lstStyle/>
+          <a:p>
+            <a:r>
+              <a:rPr lang="it-IT" dirty="0"/>
+              <a:t>Theory </a:t>
+            </a:r>
+            <a:r>
+              <a:rPr lang="it-IT" dirty="0" err="1"/>
+              <a:t>program</a:t>
+            </a:r>
+            <a:endParaRPr lang="en-GB" dirty="0"/>
+          </a:p>
+        </p:txBody>
+      </p:sp>
+      <p:sp>
+        <p:nvSpPr>
+          <p:cNvPr id="6" name="Segnaposto contenuto 5"/>
+          <p:cNvSpPr>
+            <a:spLocks noGrp="1"/>
+          </p:cNvSpPr>
+          <p:nvPr>
+            <p:ph idx="1"/>
+          </p:nvPr>
+        </p:nvSpPr>
+        <p:spPr/>
+        <p:txBody>
+          <a:bodyPr/>
+          <a:lstStyle/>
+          <a:p>
+            <a:r>
+              <a:rPr lang="en-GB" dirty="0"/>
+              <a:t>12 theory lectures</a:t>
+            </a:r>
+          </a:p>
+          <a:p>
+            <a:pPr lvl="1"/>
+            <a:r>
+              <a:rPr lang="en-GB" dirty="0"/>
+              <a:t>Tuesday 14:30-16:30, Room Me (Polo </a:t>
+            </a:r>
+            <a:r>
+              <a:rPr lang="en-GB" dirty="0" err="1"/>
+              <a:t>Didattico</a:t>
+            </a:r>
+            <a:r>
+              <a:rPr lang="en-GB" dirty="0"/>
+              <a:t> di Via </a:t>
+            </a:r>
+            <a:r>
+              <a:rPr lang="en-GB" dirty="0" err="1"/>
+              <a:t>Gradenigo</a:t>
+            </a:r>
+            <a:r>
+              <a:rPr lang="en-GB" dirty="0"/>
+              <a:t>)</a:t>
+            </a:r>
+          </a:p>
+          <a:p>
+            <a:pPr lvl="1"/>
+            <a:endParaRPr lang="en-GB" b="1" dirty="0"/>
+          </a:p>
+          <a:p>
+            <a:r>
+              <a:rPr lang="en-GB" dirty="0"/>
+              <a:t>Contents: </a:t>
+            </a:r>
+          </a:p>
+          <a:p>
+            <a:pPr lvl="1"/>
+            <a:r>
+              <a:rPr lang="en-GB" dirty="0"/>
+              <a:t>Wearable sensor technologies</a:t>
+            </a:r>
+          </a:p>
+          <a:p>
+            <a:pPr lvl="1"/>
+            <a:r>
+              <a:rPr lang="en-GB" dirty="0"/>
+              <a:t>World wide web, HTTP communication protocol</a:t>
+            </a:r>
+          </a:p>
+          <a:p>
+            <a:pPr lvl="1"/>
+            <a:r>
+              <a:rPr lang="en-GB" dirty="0"/>
+              <a:t>The representational state transfer (REST) paradigm</a:t>
+            </a:r>
+          </a:p>
+          <a:p>
+            <a:pPr lvl="1"/>
+            <a:r>
+              <a:rPr lang="en-GB" dirty="0"/>
+              <a:t>Application programming interfaces (APIs)</a:t>
+            </a:r>
+          </a:p>
+          <a:p>
+            <a:pPr lvl="1"/>
+            <a:r>
+              <a:rPr lang="en-GB" dirty="0"/>
+              <a:t>Elements of cryptography</a:t>
+            </a:r>
+          </a:p>
+          <a:p>
+            <a:pPr lvl="1"/>
+            <a:r>
+              <a:rPr lang="en-GB" dirty="0"/>
+              <a:t>Authentication protocols</a:t>
+            </a:r>
+          </a:p>
+          <a:p>
+            <a:pPr lvl="1"/>
+            <a:r>
+              <a:rPr lang="en-GB" dirty="0"/>
+              <a:t>Health design thinking</a:t>
+            </a:r>
+          </a:p>
+          <a:p>
+            <a:pPr lvl="1"/>
+            <a:r>
+              <a:rPr lang="en-GB" dirty="0"/>
+              <a:t>Evaluation of app usability</a:t>
+            </a:r>
+          </a:p>
+          <a:p>
+            <a:pPr lvl="1"/>
+            <a:r>
+              <a:rPr lang="en-GB" dirty="0"/>
+              <a:t>Regulation for health data management</a:t>
+            </a:r>
+          </a:p>
+          <a:p>
+            <a:pPr lvl="1"/>
+            <a:endParaRPr lang="it-IT" dirty="0"/>
+          </a:p>
+          <a:p>
+            <a:endParaRPr lang="it-IT" dirty="0"/>
+          </a:p>
+          <a:p>
+            <a:endParaRPr lang="it-IT" dirty="0"/>
+          </a:p>
+        </p:txBody>
+      </p:sp>
+      <p:sp>
+        <p:nvSpPr>
+          <p:cNvPr id="2" name="Segnaposto numero diapositiva 1"/>
+          <p:cNvSpPr>
+            <a:spLocks noGrp="1"/>
+          </p:cNvSpPr>
+          <p:nvPr>
+            <p:ph type="sldNum" sz="quarter" idx="12"/>
+          </p:nvPr>
+        </p:nvSpPr>
+        <p:spPr/>
+        <p:txBody>
+          <a:bodyPr/>
+          <a:lstStyle/>
+          <a:p>
+            <a:fld id="{31DE2C5B-556E-47B8-A792-024C2FCA4ACC}" type="slidenum">
+              <a:rPr lang="en-GB" smtClean="0"/>
+              <a:t>25</a:t>
+            </a:fld>
+            <a:endParaRPr lang="en-GB"/>
+          </a:p>
+        </p:txBody>
+      </p:sp>
+    </p:spTree>
+    <p:extLst>
+      <p:ext uri="{BB962C8B-B14F-4D97-AF65-F5344CB8AC3E}">
+        <p14:creationId xmlns:p14="http://schemas.microsoft.com/office/powerpoint/2010/main" val="1427573288"/>
+      </p:ext>
+    </p:extLst>
+  </p:cSld>
+  <p:clrMapOvr>
+    <a:masterClrMapping/>
+  </p:clrMapOvr>
+</p:sld>
+</file>
+
 <file path=ppt/slides/slide26.xml><?xml version="1.0" encoding="utf-8"?>
 <p:sld xmlns:a="http://schemas.openxmlformats.org/drawingml/2006/main" xmlns:r="http://schemas.openxmlformats.org/officeDocument/2006/relationships" xmlns:p="http://schemas.openxmlformats.org/presentationml/2006/main">
   <p:cSld>
@@ -14837,7 +14269,7 @@
           <a:p>
             <a:r>
               <a:rPr lang="it-IT" dirty="0"/>
-              <a:t>Theory </a:t>
+              <a:t>Lab </a:t>
             </a:r>
             <a:r>
               <a:rPr lang="it-IT" dirty="0" err="1"/>
@@ -14859,19 +14291,29 @@
         </p:nvSpPr>
         <p:spPr/>
         <p:txBody>
-          <a:bodyPr/>
+          <a:bodyPr>
+            <a:normAutofit/>
+          </a:bodyPr>
           <a:lstStyle/>
           <a:p>
             <a:r>
               <a:rPr lang="en-GB" dirty="0"/>
-              <a:t>12 theory lectures</a:t>
+              <a:t>12 laboratory lectures (11 lectures + 1 workshop)</a:t>
             </a:r>
           </a:p>
           <a:p>
             <a:pPr lvl="1"/>
             <a:r>
               <a:rPr lang="en-GB" dirty="0"/>
-              <a:t>Tuesday 14:30-16:30, Room Me (Polo </a:t>
+              <a:t>Wednesday 8:30-10:30, Rooms </a:t>
+            </a:r>
+            <a:r>
+              <a:rPr lang="en-GB" dirty="0" err="1"/>
+              <a:t>Te+Ue</a:t>
+            </a:r>
+            <a:r>
+              <a:rPr lang="en-GB" dirty="0"/>
+              <a:t> (Polo </a:t>
             </a:r>
             <a:r>
               <a:rPr lang="en-GB" dirty="0" err="1"/>
@@ -14892,7 +14334,7 @@
           </a:p>
           <a:p>
             <a:pPr lvl="1"/>
-            <a:endParaRPr lang="en-GB" b="1" dirty="0"/>
+            <a:endParaRPr lang="en-GB" dirty="0"/>
           </a:p>
           <a:p>
             <a:r>
@@ -14904,74 +14346,61 @@
             <a:pPr lvl="1"/>
             <a:r>
               <a:rPr lang="en-GB" dirty="0"/>
-              <a:t>Wearable sensor technologies</a:t>
+              <a:t>The Git version control system</a:t>
             </a:r>
           </a:p>
           <a:p>
             <a:pPr lvl="1"/>
             <a:r>
               <a:rPr lang="en-GB" dirty="0"/>
-              <a:t>World wide web, HTTP communication protocol</a:t>
+              <a:t>Dart programming language and the Flutter framework</a:t>
             </a:r>
           </a:p>
           <a:p>
             <a:pPr lvl="1"/>
             <a:r>
               <a:rPr lang="en-GB" dirty="0"/>
-              <a:t>The representational state transfer (REST) paradigm</a:t>
+              <a:t>Building mobile/web applications in Flutter</a:t>
             </a:r>
           </a:p>
           <a:p>
             <a:pPr lvl="1"/>
             <a:r>
               <a:rPr lang="en-GB" dirty="0"/>
-              <a:t>Application programming interfaces (APIs)</a:t>
+              <a:t>User Interface design</a:t>
             </a:r>
           </a:p>
           <a:p>
             <a:pPr lvl="1"/>
             <a:r>
               <a:rPr lang="en-GB" dirty="0"/>
-              <a:t>Elements of cryptography</a:t>
+              <a:t>Navigation</a:t>
             </a:r>
           </a:p>
           <a:p>
             <a:pPr lvl="1"/>
             <a:r>
               <a:rPr lang="en-GB" dirty="0"/>
-              <a:t>Authentication protocols</a:t>
+              <a:t>State management</a:t>
             </a:r>
           </a:p>
           <a:p>
             <a:pPr lvl="1"/>
             <a:r>
               <a:rPr lang="en-GB" dirty="0"/>
-              <a:t>Health design thinking</a:t>
+              <a:t>Basic data persistence</a:t>
             </a:r>
           </a:p>
           <a:p>
             <a:pPr lvl="1"/>
             <a:r>
               <a:rPr lang="en-GB" dirty="0"/>
-              <a:t>Evaluation of app usability</a:t>
+              <a:t>Networking</a:t>
             </a:r>
           </a:p>
           <a:p>
             <a:pPr lvl="1"/>
-            <a:r>
-              <a:rPr lang="en-GB" dirty="0"/>
-              <a:t>Regulation for health data management</a:t>
-            </a:r>
-          </a:p>
-          <a:p>
-            <a:pPr lvl="1"/>
-            <a:endParaRPr lang="it-IT" dirty="0"/>
-          </a:p>
-          <a:p>
-            <a:endParaRPr lang="it-IT" dirty="0"/>
-          </a:p>
-          <a:p>
-            <a:endParaRPr lang="it-IT" dirty="0"/>
+            <a:endParaRPr lang="en-GB" dirty="0"/>
           </a:p>
         </p:txBody>
       </p:sp>
@@ -14993,211 +14422,6 @@
             <a:fld id="{31DE2C5B-556E-47B8-A792-024C2FCA4ACC}" type="slidenum">
               <a:rPr lang="en-GB" smtClean="0"/>
               <a:t>26</a:t>
-            </a:fld>
-            <a:endParaRPr lang="en-GB"/>
-          </a:p>
-        </p:txBody>
-      </p:sp>
-    </p:spTree>
-    <p:extLst>
-      <p:ext uri="{BB962C8B-B14F-4D97-AF65-F5344CB8AC3E}">
-        <p14:creationId xmlns:p14="http://schemas.microsoft.com/office/powerpoint/2010/main" val="1427573288"/>
-      </p:ext>
-    </p:extLst>
-  </p:cSld>
-  <p:clrMapOvr>
-    <a:masterClrMapping/>
-  </p:clrMapOvr>
-</p:sld>
-</file>
-
-<file path=ppt/slides/slide27.xml><?xml version="1.0" encoding="utf-8"?>
-<p:sld xmlns:a="http://schemas.openxmlformats.org/drawingml/2006/main" xmlns:r="http://schemas.openxmlformats.org/officeDocument/2006/relationships" xmlns:p="http://schemas.openxmlformats.org/presentationml/2006/main">
-  <p:cSld>
-    <p:spTree>
-      <p:nvGrpSpPr>
-        <p:cNvPr id="1" name=""/>
-        <p:cNvGrpSpPr/>
-        <p:nvPr/>
-      </p:nvGrpSpPr>
-      <p:grpSpPr>
-        <a:xfrm>
-          <a:off x="0" y="0"/>
-          <a:ext cx="0" cy="0"/>
-          <a:chOff x="0" y="0"/>
-          <a:chExt cx="0" cy="0"/>
-        </a:xfrm>
-      </p:grpSpPr>
-      <p:sp>
-        <p:nvSpPr>
-          <p:cNvPr id="5" name="Titolo 4"/>
-          <p:cNvSpPr>
-            <a:spLocks noGrp="1"/>
-          </p:cNvSpPr>
-          <p:nvPr>
-            <p:ph type="title"/>
-          </p:nvPr>
-        </p:nvSpPr>
-        <p:spPr/>
-        <p:txBody>
-          <a:bodyPr/>
-          <a:lstStyle/>
-          <a:p>
-            <a:r>
-              <a:rPr lang="it-IT" dirty="0"/>
-              <a:t>Lab </a:t>
-            </a:r>
-            <a:r>
-              <a:rPr lang="it-IT" dirty="0" err="1"/>
-              <a:t>program</a:t>
-            </a:r>
-            <a:endParaRPr lang="en-GB" dirty="0"/>
-          </a:p>
-        </p:txBody>
-      </p:sp>
-      <p:sp>
-        <p:nvSpPr>
-          <p:cNvPr id="6" name="Segnaposto contenuto 5"/>
-          <p:cNvSpPr>
-            <a:spLocks noGrp="1"/>
-          </p:cNvSpPr>
-          <p:nvPr>
-            <p:ph idx="1"/>
-          </p:nvPr>
-        </p:nvSpPr>
-        <p:spPr/>
-        <p:txBody>
-          <a:bodyPr>
-            <a:normAutofit/>
-          </a:bodyPr>
-          <a:lstStyle/>
-          <a:p>
-            <a:r>
-              <a:rPr lang="en-GB" dirty="0"/>
-              <a:t>12 laboratory lectures (11 lectures + 1 workshop)</a:t>
-            </a:r>
-          </a:p>
-          <a:p>
-            <a:pPr lvl="1"/>
-            <a:r>
-              <a:rPr lang="en-GB" dirty="0"/>
-              <a:t>Wednesday 8:30-10:30, Rooms </a:t>
-            </a:r>
-            <a:r>
-              <a:rPr lang="en-GB" dirty="0" err="1"/>
-              <a:t>Te+Ue</a:t>
-            </a:r>
-            <a:r>
-              <a:rPr lang="en-GB" dirty="0"/>
-              <a:t> (Polo </a:t>
-            </a:r>
-            <a:r>
-              <a:rPr lang="en-GB" dirty="0" err="1"/>
-              <a:t>Didattico</a:t>
-            </a:r>
-            <a:r>
-              <a:rPr lang="en-GB" dirty="0"/>
-              <a:t> di Via </a:t>
-            </a:r>
-            <a:r>
-              <a:rPr lang="en-GB" dirty="0" err="1"/>
-              <a:t>Gradenigo</a:t>
-            </a:r>
-            <a:r>
-              <a:rPr lang="en-GB" dirty="0"/>
-              <a:t>)</a:t>
-            </a:r>
-          </a:p>
-          <a:p>
-            <a:pPr lvl="1"/>
-            <a:endParaRPr lang="en-GB" dirty="0"/>
-          </a:p>
-          <a:p>
-            <a:r>
-              <a:rPr lang="en-GB" dirty="0"/>
-              <a:t>Contents: </a:t>
-            </a:r>
-          </a:p>
-          <a:p>
-            <a:pPr lvl="1"/>
-            <a:r>
-              <a:rPr lang="en-GB" dirty="0"/>
-              <a:t>The Git version control system</a:t>
-            </a:r>
-          </a:p>
-          <a:p>
-            <a:pPr lvl="1"/>
-            <a:r>
-              <a:rPr lang="en-GB" dirty="0"/>
-              <a:t>Dart programming language and the Flutter framework</a:t>
-            </a:r>
-          </a:p>
-          <a:p>
-            <a:pPr lvl="1"/>
-            <a:r>
-              <a:rPr lang="en-GB" dirty="0"/>
-              <a:t>Building mobile/web applications in Flutter</a:t>
-            </a:r>
-          </a:p>
-          <a:p>
-            <a:pPr lvl="1"/>
-            <a:r>
-              <a:rPr lang="en-GB" dirty="0"/>
-              <a:t>User Interface design</a:t>
-            </a:r>
-          </a:p>
-          <a:p>
-            <a:pPr lvl="1"/>
-            <a:r>
-              <a:rPr lang="en-GB" dirty="0"/>
-              <a:t>Navigation</a:t>
-            </a:r>
-          </a:p>
-          <a:p>
-            <a:pPr lvl="1"/>
-            <a:r>
-              <a:rPr lang="en-GB" dirty="0"/>
-              <a:t>State management</a:t>
-            </a:r>
-          </a:p>
-          <a:p>
-            <a:pPr lvl="1"/>
-            <a:r>
-              <a:rPr lang="en-GB" dirty="0"/>
-              <a:t>Basic data persistence</a:t>
-            </a:r>
-          </a:p>
-          <a:p>
-            <a:pPr lvl="1"/>
-            <a:r>
-              <a:rPr lang="en-GB" dirty="0"/>
-              <a:t>Networking</a:t>
-            </a:r>
-          </a:p>
-          <a:p>
-            <a:pPr lvl="1"/>
-            <a:endParaRPr lang="en-GB" dirty="0"/>
-          </a:p>
-        </p:txBody>
-      </p:sp>
-      <p:sp>
-        <p:nvSpPr>
-          <p:cNvPr id="2" name="Segnaposto numero diapositiva 1"/>
-          <p:cNvSpPr>
-            <a:spLocks noGrp="1"/>
-          </p:cNvSpPr>
-          <p:nvPr>
-            <p:ph type="sldNum" sz="quarter" idx="12"/>
-          </p:nvPr>
-        </p:nvSpPr>
-        <p:spPr/>
-        <p:txBody>
-          <a:bodyPr/>
-          <a:lstStyle/>
-          <a:p>
-            <a:fld id="{31DE2C5B-556E-47B8-A792-024C2FCA4ACC}" type="slidenum">
-              <a:rPr lang="en-GB" smtClean="0"/>
-              <a:t>27</a:t>
             </a:fld>
             <a:endParaRPr lang="en-GB"/>
           </a:p>
@@ -15216,7 +14440,7 @@
 </p:sld>
 </file>
 
-<file path=ppt/slides/slide28.xml><?xml version="1.0" encoding="utf-8"?>
+<file path=ppt/slides/slide27.xml><?xml version="1.0" encoding="utf-8"?>
 <p:sld xmlns:a="http://schemas.openxmlformats.org/drawingml/2006/main" xmlns:r="http://schemas.openxmlformats.org/officeDocument/2006/relationships" xmlns:p="http://schemas.openxmlformats.org/presentationml/2006/main">
   <p:cSld>
     <p:spTree>
@@ -15492,7 +14716,7 @@
           <a:p>
             <a:fld id="{31DE2C5B-556E-47B8-A792-024C2FCA4ACC}" type="slidenum">
               <a:rPr lang="en-GB" smtClean="0"/>
-              <a:t>28</a:t>
+              <a:t>27</a:t>
             </a:fld>
             <a:endParaRPr lang="en-GB"/>
           </a:p>
@@ -15511,7 +14735,7 @@
 </p:sld>
 </file>
 
-<file path=ppt/slides/slide29.xml><?xml version="1.0" encoding="utf-8"?>
+<file path=ppt/slides/slide28.xml><?xml version="1.0" encoding="utf-8"?>
 <p:sld xmlns:a="http://schemas.openxmlformats.org/drawingml/2006/main" xmlns:r="http://schemas.openxmlformats.org/officeDocument/2006/relationships" xmlns:p="http://schemas.openxmlformats.org/presentationml/2006/main">
   <p:cSld>
     <p:spTree>
@@ -15636,7 +14860,7 @@
           <a:p>
             <a:fld id="{31DE2C5B-556E-47B8-A792-024C2FCA4ACC}" type="slidenum">
               <a:rPr lang="en-GB" smtClean="0"/>
-              <a:t>29</a:t>
+              <a:t>28</a:t>
             </a:fld>
             <a:endParaRPr lang="en-GB"/>
           </a:p>
@@ -16519,229 +15743,7 @@
 </p:sld>
 </file>
 
-<file path=ppt/slides/slide3.xml><?xml version="1.0" encoding="utf-8"?>
-<p:sld xmlns:a="http://schemas.openxmlformats.org/drawingml/2006/main" xmlns:r="http://schemas.openxmlformats.org/officeDocument/2006/relationships" xmlns:p="http://schemas.openxmlformats.org/presentationml/2006/main">
-  <p:cSld>
-    <p:spTree>
-      <p:nvGrpSpPr>
-        <p:cNvPr id="1" name=""/>
-        <p:cNvGrpSpPr/>
-        <p:nvPr/>
-      </p:nvGrpSpPr>
-      <p:grpSpPr>
-        <a:xfrm>
-          <a:off x="0" y="0"/>
-          <a:ext cx="0" cy="0"/>
-          <a:chOff x="0" y="0"/>
-          <a:chExt cx="0" cy="0"/>
-        </a:xfrm>
-      </p:grpSpPr>
-      <p:sp>
-        <p:nvSpPr>
-          <p:cNvPr id="3" name="Titolo 2"/>
-          <p:cNvSpPr>
-            <a:spLocks noGrp="1"/>
-          </p:cNvSpPr>
-          <p:nvPr>
-            <p:ph type="title"/>
-          </p:nvPr>
-        </p:nvSpPr>
-        <p:spPr/>
-        <p:txBody>
-          <a:bodyPr/>
-          <a:lstStyle/>
-          <a:p>
-            <a:r>
-              <a:rPr lang="it-IT" dirty="0"/>
-              <a:t>Who </a:t>
-            </a:r>
-            <a:r>
-              <a:rPr lang="it-IT" dirty="0" err="1"/>
-              <a:t>am</a:t>
-            </a:r>
-            <a:r>
-              <a:rPr lang="it-IT" dirty="0"/>
-              <a:t> I</a:t>
-            </a:r>
-            <a:endParaRPr lang="en-GB" dirty="0"/>
-          </a:p>
-        </p:txBody>
-      </p:sp>
-      <p:sp>
-        <p:nvSpPr>
-          <p:cNvPr id="4" name="Segnaposto contenuto 3"/>
-          <p:cNvSpPr>
-            <a:spLocks noGrp="1"/>
-          </p:cNvSpPr>
-          <p:nvPr>
-            <p:ph idx="1"/>
-          </p:nvPr>
-        </p:nvSpPr>
-        <p:spPr>
-          <a:xfrm>
-            <a:off x="428173" y="1361167"/>
-            <a:ext cx="7460051" cy="4858203"/>
-          </a:xfrm>
-        </p:spPr>
-        <p:txBody>
-          <a:bodyPr/>
-          <a:lstStyle/>
-          <a:p>
-            <a:r>
-              <a:rPr lang="en-GB" b="1" dirty="0"/>
-              <a:t>Giacomo Cappon</a:t>
-            </a:r>
-          </a:p>
-          <a:p>
-            <a:pPr lvl="1"/>
-            <a:r>
-              <a:rPr lang="en-GB" dirty="0"/>
-              <a:t>Assistant Professor, Department of Information Engineering, University of Padova</a:t>
-            </a:r>
-          </a:p>
-          <a:p>
-            <a:pPr lvl="1"/>
-            <a:r>
-              <a:rPr lang="en-GB" dirty="0"/>
-              <a:t>PhD in Information Engineering, curriculum Bioengineering</a:t>
-            </a:r>
-          </a:p>
-          <a:p>
-            <a:pPr lvl="1"/>
-            <a:r>
-              <a:rPr lang="en-GB" dirty="0"/>
-              <a:t>Main research interests: signal processing; decision support systems; wearable sensors; digital health; ai for medicine</a:t>
-            </a:r>
-          </a:p>
-          <a:p>
-            <a:pPr marL="457200" lvl="1" indent="0">
-              <a:buNone/>
-            </a:pPr>
-            <a:endParaRPr lang="en-GB" dirty="0"/>
-          </a:p>
-          <a:p>
-            <a:r>
-              <a:rPr lang="en-GB" dirty="0"/>
-              <a:t>Contacts</a:t>
-            </a:r>
-          </a:p>
-          <a:p>
-            <a:pPr lvl="1"/>
-            <a:r>
-              <a:rPr lang="en-GB" dirty="0"/>
-              <a:t>email: </a:t>
-            </a:r>
-            <a:r>
-              <a:rPr lang="en-GB" dirty="0">
-                <a:hlinkClick r:id="rId2"/>
-              </a:rPr>
-              <a:t>giacomo.cappon@unipd.it</a:t>
-            </a:r>
-            <a:endParaRPr lang="en-GB" dirty="0"/>
-          </a:p>
-          <a:p>
-            <a:pPr lvl="1"/>
-            <a:r>
-              <a:rPr lang="en-GB" dirty="0"/>
-              <a:t>personal website: </a:t>
-            </a:r>
-            <a:r>
-              <a:rPr lang="en-GB" dirty="0">
-                <a:hlinkClick r:id="rId3"/>
-              </a:rPr>
-              <a:t>https://gcappon.github.io</a:t>
-            </a:r>
-            <a:r>
-              <a:rPr lang="en-GB" dirty="0"/>
-              <a:t>  </a:t>
-            </a:r>
-          </a:p>
-          <a:p>
-            <a:pPr lvl="1"/>
-            <a:r>
-              <a:rPr lang="en-GB" dirty="0"/>
-              <a:t>public repos: </a:t>
-            </a:r>
-            <a:r>
-              <a:rPr lang="en-GB" dirty="0">
-                <a:hlinkClick r:id="rId4"/>
-              </a:rPr>
-              <a:t>https://github.com/gcappon</a:t>
-            </a:r>
-            <a:r>
-              <a:rPr lang="en-GB" dirty="0"/>
-              <a:t> </a:t>
-            </a:r>
-          </a:p>
-        </p:txBody>
-      </p:sp>
-      <p:pic>
-        <p:nvPicPr>
-          <p:cNvPr id="2" name="Immagine 1"/>
-          <p:cNvPicPr>
-            <a:picLocks noChangeAspect="1"/>
-          </p:cNvPicPr>
-          <p:nvPr/>
-        </p:nvPicPr>
-        <p:blipFill>
-          <a:blip r:embed="rId5">
-            <a:extLst>
-              <a:ext uri="{28A0092B-C50C-407E-A947-70E740481C1C}">
-                <a14:useLocalDpi xmlns:a14="http://schemas.microsoft.com/office/drawing/2010/main" val="0"/>
-              </a:ext>
-            </a:extLst>
-          </a:blip>
-          <a:stretch>
-            <a:fillRect/>
-          </a:stretch>
-        </p:blipFill>
-        <p:spPr>
-          <a:xfrm>
-            <a:off x="8887968" y="1724071"/>
-            <a:ext cx="2168039" cy="2168039"/>
-          </a:xfrm>
-          <a:prstGeom prst="rect">
-            <a:avLst/>
-          </a:prstGeom>
-        </p:spPr>
-      </p:pic>
-      <p:sp>
-        <p:nvSpPr>
-          <p:cNvPr id="6" name="Segnaposto numero diapositiva 5"/>
-          <p:cNvSpPr>
-            <a:spLocks noGrp="1"/>
-          </p:cNvSpPr>
-          <p:nvPr>
-            <p:ph type="sldNum" sz="quarter" idx="12"/>
-          </p:nvPr>
-        </p:nvSpPr>
-        <p:spPr/>
-        <p:txBody>
-          <a:bodyPr/>
-          <a:lstStyle/>
-          <a:p>
-            <a:fld id="{31DE2C5B-556E-47B8-A792-024C2FCA4ACC}" type="slidenum">
-              <a:rPr lang="en-GB" smtClean="0"/>
-              <a:t>3</a:t>
-            </a:fld>
-            <a:endParaRPr lang="en-GB"/>
-          </a:p>
-        </p:txBody>
-      </p:sp>
-    </p:spTree>
-    <p:extLst>
-      <p:ext uri="{BB962C8B-B14F-4D97-AF65-F5344CB8AC3E}">
-        <p14:creationId xmlns:p14="http://schemas.microsoft.com/office/powerpoint/2010/main" val="3666219517"/>
-      </p:ext>
-    </p:extLst>
-  </p:cSld>
-  <p:clrMapOvr>
-    <a:masterClrMapping/>
-  </p:clrMapOvr>
-</p:sld>
-</file>
-
-<file path=ppt/slides/slide30.xml><?xml version="1.0" encoding="utf-8"?>
+<file path=ppt/slides/slide29.xml><?xml version="1.0" encoding="utf-8"?>
 <p:sld xmlns:a="http://schemas.openxmlformats.org/drawingml/2006/main" xmlns:r="http://schemas.openxmlformats.org/officeDocument/2006/relationships" xmlns:p="http://schemas.openxmlformats.org/presentationml/2006/main">
   <p:cSld>
     <p:spTree>
@@ -16939,7 +15941,7 @@
           <a:p>
             <a:fld id="{31DE2C5B-556E-47B8-A792-024C2FCA4ACC}" type="slidenum">
               <a:rPr lang="en-GB" smtClean="0"/>
-              <a:t>30</a:t>
+              <a:t>29</a:t>
             </a:fld>
             <a:endParaRPr lang="en-GB"/>
           </a:p>
@@ -17036,7 +16038,229 @@
 </p:sld>
 </file>
 
-<file path=ppt/slides/slide31.xml><?xml version="1.0" encoding="utf-8"?>
+<file path=ppt/slides/slide3.xml><?xml version="1.0" encoding="utf-8"?>
+<p:sld xmlns:a="http://schemas.openxmlformats.org/drawingml/2006/main" xmlns:r="http://schemas.openxmlformats.org/officeDocument/2006/relationships" xmlns:p="http://schemas.openxmlformats.org/presentationml/2006/main">
+  <p:cSld>
+    <p:spTree>
+      <p:nvGrpSpPr>
+        <p:cNvPr id="1" name=""/>
+        <p:cNvGrpSpPr/>
+        <p:nvPr/>
+      </p:nvGrpSpPr>
+      <p:grpSpPr>
+        <a:xfrm>
+          <a:off x="0" y="0"/>
+          <a:ext cx="0" cy="0"/>
+          <a:chOff x="0" y="0"/>
+          <a:chExt cx="0" cy="0"/>
+        </a:xfrm>
+      </p:grpSpPr>
+      <p:sp>
+        <p:nvSpPr>
+          <p:cNvPr id="3" name="Titolo 2"/>
+          <p:cNvSpPr>
+            <a:spLocks noGrp="1"/>
+          </p:cNvSpPr>
+          <p:nvPr>
+            <p:ph type="title"/>
+          </p:nvPr>
+        </p:nvSpPr>
+        <p:spPr/>
+        <p:txBody>
+          <a:bodyPr/>
+          <a:lstStyle/>
+          <a:p>
+            <a:r>
+              <a:rPr lang="it-IT" dirty="0"/>
+              <a:t>Who </a:t>
+            </a:r>
+            <a:r>
+              <a:rPr lang="it-IT" dirty="0" err="1"/>
+              <a:t>am</a:t>
+            </a:r>
+            <a:r>
+              <a:rPr lang="it-IT" dirty="0"/>
+              <a:t> I</a:t>
+            </a:r>
+            <a:endParaRPr lang="en-GB" dirty="0"/>
+          </a:p>
+        </p:txBody>
+      </p:sp>
+      <p:sp>
+        <p:nvSpPr>
+          <p:cNvPr id="4" name="Segnaposto contenuto 3"/>
+          <p:cNvSpPr>
+            <a:spLocks noGrp="1"/>
+          </p:cNvSpPr>
+          <p:nvPr>
+            <p:ph idx="1"/>
+          </p:nvPr>
+        </p:nvSpPr>
+        <p:spPr>
+          <a:xfrm>
+            <a:off x="428173" y="1361167"/>
+            <a:ext cx="7460051" cy="4858203"/>
+          </a:xfrm>
+        </p:spPr>
+        <p:txBody>
+          <a:bodyPr/>
+          <a:lstStyle/>
+          <a:p>
+            <a:r>
+              <a:rPr lang="en-GB" b="1" dirty="0"/>
+              <a:t>Giacomo Cappon</a:t>
+            </a:r>
+          </a:p>
+          <a:p>
+            <a:pPr lvl="1"/>
+            <a:r>
+              <a:rPr lang="en-GB" dirty="0"/>
+              <a:t>Assistant Professor, Department of Information Engineering, University of Padova</a:t>
+            </a:r>
+          </a:p>
+          <a:p>
+            <a:pPr lvl="1"/>
+            <a:r>
+              <a:rPr lang="en-GB" dirty="0"/>
+              <a:t>PhD in Information Engineering, curriculum Bioengineering</a:t>
+            </a:r>
+          </a:p>
+          <a:p>
+            <a:pPr lvl="1"/>
+            <a:r>
+              <a:rPr lang="en-GB" dirty="0"/>
+              <a:t>Main research interests: signal processing; decision support systems; wearable sensors; digital health; ai for medicine</a:t>
+            </a:r>
+          </a:p>
+          <a:p>
+            <a:pPr marL="457200" lvl="1" indent="0">
+              <a:buNone/>
+            </a:pPr>
+            <a:endParaRPr lang="en-GB" dirty="0"/>
+          </a:p>
+          <a:p>
+            <a:r>
+              <a:rPr lang="en-GB" dirty="0"/>
+              <a:t>Contacts</a:t>
+            </a:r>
+          </a:p>
+          <a:p>
+            <a:pPr lvl="1"/>
+            <a:r>
+              <a:rPr lang="en-GB" dirty="0"/>
+              <a:t>email: </a:t>
+            </a:r>
+            <a:r>
+              <a:rPr lang="en-GB" dirty="0">
+                <a:hlinkClick r:id="rId2"/>
+              </a:rPr>
+              <a:t>giacomo.cappon@unipd.it</a:t>
+            </a:r>
+            <a:endParaRPr lang="en-GB" dirty="0"/>
+          </a:p>
+          <a:p>
+            <a:pPr lvl="1"/>
+            <a:r>
+              <a:rPr lang="en-GB" dirty="0"/>
+              <a:t>personal website: </a:t>
+            </a:r>
+            <a:r>
+              <a:rPr lang="en-GB" dirty="0">
+                <a:hlinkClick r:id="rId3"/>
+              </a:rPr>
+              <a:t>https://gcappon.github.io</a:t>
+            </a:r>
+            <a:r>
+              <a:rPr lang="en-GB" dirty="0"/>
+              <a:t>  </a:t>
+            </a:r>
+          </a:p>
+          <a:p>
+            <a:pPr lvl="1"/>
+            <a:r>
+              <a:rPr lang="en-GB" dirty="0"/>
+              <a:t>public repos: </a:t>
+            </a:r>
+            <a:r>
+              <a:rPr lang="en-GB" dirty="0">
+                <a:hlinkClick r:id="rId4"/>
+              </a:rPr>
+              <a:t>https://github.com/gcappon</a:t>
+            </a:r>
+            <a:r>
+              <a:rPr lang="en-GB" dirty="0"/>
+              <a:t> </a:t>
+            </a:r>
+          </a:p>
+        </p:txBody>
+      </p:sp>
+      <p:pic>
+        <p:nvPicPr>
+          <p:cNvPr id="2" name="Immagine 1"/>
+          <p:cNvPicPr>
+            <a:picLocks noChangeAspect="1"/>
+          </p:cNvPicPr>
+          <p:nvPr/>
+        </p:nvPicPr>
+        <p:blipFill>
+          <a:blip r:embed="rId5">
+            <a:extLst>
+              <a:ext uri="{28A0092B-C50C-407E-A947-70E740481C1C}">
+                <a14:useLocalDpi xmlns:a14="http://schemas.microsoft.com/office/drawing/2010/main" val="0"/>
+              </a:ext>
+            </a:extLst>
+          </a:blip>
+          <a:stretch>
+            <a:fillRect/>
+          </a:stretch>
+        </p:blipFill>
+        <p:spPr>
+          <a:xfrm>
+            <a:off x="8887968" y="1724071"/>
+            <a:ext cx="2168039" cy="2168039"/>
+          </a:xfrm>
+          <a:prstGeom prst="rect">
+            <a:avLst/>
+          </a:prstGeom>
+        </p:spPr>
+      </p:pic>
+      <p:sp>
+        <p:nvSpPr>
+          <p:cNvPr id="6" name="Segnaposto numero diapositiva 5"/>
+          <p:cNvSpPr>
+            <a:spLocks noGrp="1"/>
+          </p:cNvSpPr>
+          <p:nvPr>
+            <p:ph type="sldNum" sz="quarter" idx="12"/>
+          </p:nvPr>
+        </p:nvSpPr>
+        <p:spPr/>
+        <p:txBody>
+          <a:bodyPr/>
+          <a:lstStyle/>
+          <a:p>
+            <a:fld id="{31DE2C5B-556E-47B8-A792-024C2FCA4ACC}" type="slidenum">
+              <a:rPr lang="en-GB" smtClean="0"/>
+              <a:t>3</a:t>
+            </a:fld>
+            <a:endParaRPr lang="en-GB"/>
+          </a:p>
+        </p:txBody>
+      </p:sp>
+    </p:spTree>
+    <p:extLst>
+      <p:ext uri="{BB962C8B-B14F-4D97-AF65-F5344CB8AC3E}">
+        <p14:creationId xmlns:p14="http://schemas.microsoft.com/office/powerpoint/2010/main" val="3666219517"/>
+      </p:ext>
+    </p:extLst>
+  </p:cSld>
+  <p:clrMapOvr>
+    <a:masterClrMapping/>
+  </p:clrMapOvr>
+</p:sld>
+</file>
+
+<file path=ppt/slides/slide30.xml><?xml version="1.0" encoding="utf-8"?>
 <p:sld xmlns:a="http://schemas.openxmlformats.org/drawingml/2006/main" xmlns:r="http://schemas.openxmlformats.org/officeDocument/2006/relationships" xmlns:p="http://schemas.openxmlformats.org/presentationml/2006/main">
   <p:cSld>
     <p:spTree>
@@ -17303,7 +16527,7 @@
           <a:p>
             <a:fld id="{31DE2C5B-556E-47B8-A792-024C2FCA4ACC}" type="slidenum">
               <a:rPr lang="en-GB" smtClean="0"/>
-              <a:t>31</a:t>
+              <a:t>30</a:t>
             </a:fld>
             <a:endParaRPr lang="en-GB"/>
           </a:p>
@@ -17322,7 +16546,7 @@
 </p:sld>
 </file>
 
-<file path=ppt/slides/slide32.xml><?xml version="1.0" encoding="utf-8"?>
+<file path=ppt/slides/slide31.xml><?xml version="1.0" encoding="utf-8"?>
 <p:sld xmlns:a="http://schemas.openxmlformats.org/drawingml/2006/main" xmlns:r="http://schemas.openxmlformats.org/officeDocument/2006/relationships" xmlns:p="http://schemas.openxmlformats.org/presentationml/2006/main">
   <p:cSld>
     <p:spTree>
@@ -17651,7 +16875,7 @@
           <a:p>
             <a:fld id="{31DE2C5B-556E-47B8-A792-024C2FCA4ACC}" type="slidenum">
               <a:rPr lang="en-GB" smtClean="0"/>
-              <a:t>32</a:t>
+              <a:t>31</a:t>
             </a:fld>
             <a:endParaRPr lang="en-GB"/>
           </a:p>
@@ -17670,7 +16894,7 @@
 </p:sld>
 </file>
 
-<file path=ppt/slides/slide33.xml><?xml version="1.0" encoding="utf-8"?>
+<file path=ppt/slides/slide32.xml><?xml version="1.0" encoding="utf-8"?>
 <p:sld xmlns:a="http://schemas.openxmlformats.org/drawingml/2006/main" xmlns:r="http://schemas.openxmlformats.org/officeDocument/2006/relationships" xmlns:p="http://schemas.openxmlformats.org/presentationml/2006/main">
   <p:cSld>
     <p:spTree>
@@ -17877,7 +17101,7 @@
           <a:p>
             <a:fld id="{31DE2C5B-556E-47B8-A792-024C2FCA4ACC}" type="slidenum">
               <a:rPr lang="en-GB" smtClean="0"/>
-              <a:t>33</a:t>
+              <a:t>32</a:t>
             </a:fld>
             <a:endParaRPr lang="en-GB" dirty="0"/>
           </a:p>
@@ -17896,7 +17120,7 @@
 </p:sld>
 </file>
 
-<file path=ppt/slides/slide34.xml><?xml version="1.0" encoding="utf-8"?>
+<file path=ppt/slides/slide33.xml><?xml version="1.0" encoding="utf-8"?>
 <p:sld xmlns:a="http://schemas.openxmlformats.org/drawingml/2006/main" xmlns:r="http://schemas.openxmlformats.org/officeDocument/2006/relationships" xmlns:p="http://schemas.openxmlformats.org/presentationml/2006/main">
   <p:cSld>
     <p:spTree>
@@ -18292,7 +17516,7 @@
           <a:p>
             <a:fld id="{31DE2C5B-556E-47B8-A792-024C2FCA4ACC}" type="slidenum">
               <a:rPr lang="en-GB" smtClean="0"/>
-              <a:t>34</a:t>
+              <a:t>33</a:t>
             </a:fld>
             <a:endParaRPr lang="en-GB" dirty="0"/>
           </a:p>
@@ -18311,7 +17535,7 @@
 </p:sld>
 </file>
 
-<file path=ppt/slides/slide35.xml><?xml version="1.0" encoding="utf-8"?>
+<file path=ppt/slides/slide34.xml><?xml version="1.0" encoding="utf-8"?>
 <p:sld xmlns:a="http://schemas.openxmlformats.org/drawingml/2006/main" xmlns:r="http://schemas.openxmlformats.org/officeDocument/2006/relationships" xmlns:p="http://schemas.openxmlformats.org/presentationml/2006/main">
   <p:cSld>
     <p:spTree>
@@ -18545,7 +17769,7 @@
           <a:p>
             <a:fld id="{31DE2C5B-556E-47B8-A792-024C2FCA4ACC}" type="slidenum">
               <a:rPr lang="en-GB" smtClean="0"/>
-              <a:t>35</a:t>
+              <a:t>34</a:t>
             </a:fld>
             <a:endParaRPr lang="en-GB" dirty="0"/>
           </a:p>
@@ -18564,7 +17788,7 @@
 </p:sld>
 </file>
 
-<file path=ppt/slides/slide36.xml><?xml version="1.0" encoding="utf-8"?>
+<file path=ppt/slides/slide35.xml><?xml version="1.0" encoding="utf-8"?>
 <p:sld xmlns:a="http://schemas.openxmlformats.org/drawingml/2006/main" xmlns:r="http://schemas.openxmlformats.org/officeDocument/2006/relationships" xmlns:p="http://schemas.openxmlformats.org/presentationml/2006/main">
   <p:cSld>
     <p:spTree>
@@ -18685,7 +17909,7 @@
           <a:p>
             <a:fld id="{31DE2C5B-556E-47B8-A792-024C2FCA4ACC}" type="slidenum">
               <a:rPr lang="en-GB" smtClean="0"/>
-              <a:t>36</a:t>
+              <a:t>35</a:t>
             </a:fld>
             <a:endParaRPr lang="en-GB" dirty="0"/>
           </a:p>
@@ -18787,6 +18011,217 @@
 </p:sld>
 </file>
 
+<file path=ppt/slides/slide36.xml><?xml version="1.0" encoding="utf-8"?>
+<p:sld xmlns:a="http://schemas.openxmlformats.org/drawingml/2006/main" xmlns:r="http://schemas.openxmlformats.org/officeDocument/2006/relationships" xmlns:p="http://schemas.openxmlformats.org/presentationml/2006/main">
+  <p:cSld>
+    <p:spTree>
+      <p:nvGrpSpPr>
+        <p:cNvPr id="1" name=""/>
+        <p:cNvGrpSpPr/>
+        <p:nvPr/>
+      </p:nvGrpSpPr>
+      <p:grpSpPr>
+        <a:xfrm>
+          <a:off x="0" y="0"/>
+          <a:ext cx="0" cy="0"/>
+          <a:chOff x="0" y="0"/>
+          <a:chExt cx="0" cy="0"/>
+        </a:xfrm>
+      </p:grpSpPr>
+      <p:sp>
+        <p:nvSpPr>
+          <p:cNvPr id="2" name="Title 1">
+            <a:extLst>
+              <a:ext uri="{FF2B5EF4-FFF2-40B4-BE49-F238E27FC236}">
+                <a16:creationId xmlns:a16="http://schemas.microsoft.com/office/drawing/2014/main" id="{80BE60FB-C861-1E44-92E6-8F9396441CB2}"/>
+              </a:ext>
+            </a:extLst>
+          </p:cNvPr>
+          <p:cNvSpPr>
+            <a:spLocks noGrp="1"/>
+          </p:cNvSpPr>
+          <p:nvPr>
+            <p:ph type="title"/>
+          </p:nvPr>
+        </p:nvSpPr>
+        <p:spPr/>
+        <p:txBody>
+          <a:bodyPr>
+            <a:normAutofit/>
+          </a:bodyPr>
+          <a:lstStyle/>
+          <a:p>
+            <a:r>
+              <a:rPr lang="en-IT" dirty="0"/>
+              <a:t>Choose your target</a:t>
+            </a:r>
+          </a:p>
+        </p:txBody>
+      </p:sp>
+      <p:sp>
+        <p:nvSpPr>
+          <p:cNvPr id="3" name="Content Placeholder 2">
+            <a:extLst>
+              <a:ext uri="{FF2B5EF4-FFF2-40B4-BE49-F238E27FC236}">
+                <a16:creationId xmlns:a16="http://schemas.microsoft.com/office/drawing/2014/main" id="{ECD4BA52-23DB-D94D-9195-7777C71CD155}"/>
+              </a:ext>
+            </a:extLst>
+          </p:cNvPr>
+          <p:cNvSpPr>
+            <a:spLocks noGrp="1"/>
+          </p:cNvSpPr>
+          <p:nvPr>
+            <p:ph idx="1"/>
+          </p:nvPr>
+        </p:nvSpPr>
+        <p:spPr>
+          <a:xfrm>
+            <a:off x="428172" y="1361167"/>
+            <a:ext cx="11368314" cy="5334907"/>
+          </a:xfrm>
+        </p:spPr>
+        <p:txBody>
+          <a:bodyPr>
+            <a:normAutofit fontScale="92500" lnSpcReduction="20000"/>
+          </a:bodyPr>
+          <a:lstStyle/>
+          <a:p>
+            <a:r>
+              <a:rPr lang="en-IT" dirty="0"/>
+              <a:t>These are the target you can choose from (see </a:t>
+            </a:r>
+            <a:r>
+              <a:rPr lang="en-IT"/>
+              <a:t>the </a:t>
+            </a:r>
+            <a:r>
+              <a:rPr lang="en-US" dirty="0" err="1"/>
+              <a:t>elearning</a:t>
+            </a:r>
+            <a:r>
+              <a:rPr lang="en-IT"/>
+              <a:t> </a:t>
+            </a:r>
+            <a:r>
+              <a:rPr lang="en-IT" dirty="0"/>
+              <a:t>page for more details):</a:t>
+            </a:r>
+          </a:p>
+          <a:p>
+            <a:endParaRPr lang="en-IT" dirty="0"/>
+          </a:p>
+          <a:p>
+            <a:pPr lvl="1"/>
+            <a:r>
+              <a:rPr lang="en-GB" b="1" u="sng" dirty="0"/>
+              <a:t>SDG 2: Target 2.2</a:t>
+            </a:r>
+            <a:r>
+              <a:rPr lang="en-GB" dirty="0"/>
+              <a:t> (By 2030, end all forms of malnutrition, including achieving, by 2025, the internationally agreed targets on stunting and wasting in children under 5 years of age, and address the nutritional needs of adolescent girls, pregnant and lactating women and older persons)</a:t>
+            </a:r>
+            <a:endParaRPr lang="en-IT" dirty="0"/>
+          </a:p>
+          <a:p>
+            <a:pPr lvl="1"/>
+            <a:r>
+              <a:rPr lang="en-GB" b="1" u="sng" dirty="0"/>
+              <a:t>SDG 2: Target 2.3</a:t>
+            </a:r>
+            <a:r>
+              <a:rPr lang="en-GB" dirty="0"/>
+              <a:t> (By 2030, double the agricultural productivity and incomes of small-scale food producers, in particular women, indigenous peoples, family farmers, pastoralists and fishers, including through secure and equal access to land, other productive resources and inputs, knowledge, financial services, markets and opportunities for value addition and non-farm employment)</a:t>
+            </a:r>
+          </a:p>
+          <a:p>
+            <a:pPr lvl="1"/>
+            <a:r>
+              <a:rPr lang="en-GB" b="1" u="sng" dirty="0"/>
+              <a:t>SDG 3: Target 3.4 </a:t>
+            </a:r>
+            <a:r>
+              <a:rPr lang="en-GB" dirty="0"/>
+              <a:t>(By 2030, reduce by one third premature mortality from non-communicable diseases through prevention and treatment and promote mental health and well-being) </a:t>
+            </a:r>
+          </a:p>
+          <a:p>
+            <a:pPr lvl="1"/>
+            <a:r>
+              <a:rPr lang="en-GB" b="1" u="sng" dirty="0"/>
+              <a:t>SDG 3: Target 3.5</a:t>
+            </a:r>
+            <a:r>
+              <a:rPr lang="en-GB" dirty="0"/>
+              <a:t> (Strengthen the prevention and treatment of substance abuse, including narcotic drug abuse and harmful use of alcohol)</a:t>
+            </a:r>
+          </a:p>
+          <a:p>
+            <a:pPr lvl="1"/>
+            <a:r>
+              <a:rPr lang="en-GB" b="1" u="sng" dirty="0"/>
+              <a:t>SDG 4: Target 4.7 </a:t>
+            </a:r>
+            <a:r>
+              <a:rPr lang="en-GB" dirty="0"/>
+              <a:t>(By 2030, ensure that all learners acquire the knowledge and skills needed to promote sustainable development, including, among others, through education for sustainable development and sustainable lifestyles, human rights, gender equality, promotion of a culture of peace and non-violence, global citizenship and appreciation of cultural diversity and of culture’s contribution to sustainable development) </a:t>
+            </a:r>
+          </a:p>
+          <a:p>
+            <a:pPr lvl="1"/>
+            <a:r>
+              <a:rPr lang="en-GB" b="1" u="sng" dirty="0"/>
+              <a:t>SDG 8: Target 8.9 </a:t>
+            </a:r>
+            <a:r>
+              <a:rPr lang="en-GB" dirty="0"/>
+              <a:t>(By 2030, devise and implement policies to promote sustainable tourism that creates jobs and promotes local culture and products)</a:t>
+            </a:r>
+            <a:endParaRPr lang="en-IT" dirty="0"/>
+          </a:p>
+        </p:txBody>
+      </p:sp>
+      <p:sp>
+        <p:nvSpPr>
+          <p:cNvPr id="4" name="Slide Number Placeholder 3">
+            <a:extLst>
+              <a:ext uri="{FF2B5EF4-FFF2-40B4-BE49-F238E27FC236}">
+                <a16:creationId xmlns:a16="http://schemas.microsoft.com/office/drawing/2014/main" id="{C57ACF48-43BD-9049-83DA-4C0AF0AC5D28}"/>
+              </a:ext>
+            </a:extLst>
+          </p:cNvPr>
+          <p:cNvSpPr>
+            <a:spLocks noGrp="1"/>
+          </p:cNvSpPr>
+          <p:nvPr>
+            <p:ph type="sldNum" sz="quarter" idx="12"/>
+          </p:nvPr>
+        </p:nvSpPr>
+        <p:spPr/>
+        <p:txBody>
+          <a:bodyPr/>
+          <a:lstStyle/>
+          <a:p>
+            <a:fld id="{31DE2C5B-556E-47B8-A792-024C2FCA4ACC}" type="slidenum">
+              <a:rPr lang="en-GB" smtClean="0"/>
+              <a:t>36</a:t>
+            </a:fld>
+            <a:endParaRPr lang="en-GB" dirty="0"/>
+          </a:p>
+        </p:txBody>
+      </p:sp>
+    </p:spTree>
+    <p:extLst>
+      <p:ext uri="{BB962C8B-B14F-4D97-AF65-F5344CB8AC3E}">
+        <p14:creationId xmlns:p14="http://schemas.microsoft.com/office/powerpoint/2010/main" val="4043247871"/>
+      </p:ext>
+    </p:extLst>
+  </p:cSld>
+  <p:clrMapOvr>
+    <a:masterClrMapping/>
+  </p:clrMapOvr>
+</p:sld>
+</file>
+
 <file path=ppt/slides/slide37.xml><?xml version="1.0" encoding="utf-8"?>
 <p:sld xmlns:a="http://schemas.openxmlformats.org/drawingml/2006/main" xmlns:r="http://schemas.openxmlformats.org/officeDocument/2006/relationships" xmlns:p="http://schemas.openxmlformats.org/presentationml/2006/main">
   <p:cSld>
@@ -18829,7 +18264,7 @@
           <a:p>
             <a:r>
               <a:rPr lang="en-IT" dirty="0"/>
-              <a:t>Choose your target</a:t>
+              <a:t>Data source</a:t>
             </a:r>
           </a:p>
         </p:txBody>
@@ -18858,101 +18293,105 @@
         </p:spPr>
         <p:txBody>
           <a:bodyPr>
-            <a:normAutofit fontScale="92500" lnSpcReduction="20000"/>
+            <a:normAutofit fontScale="92500" lnSpcReduction="10000"/>
           </a:bodyPr>
           <a:lstStyle/>
           <a:p>
+            <a:endParaRPr lang="en-IT" dirty="0"/>
+          </a:p>
+          <a:p>
             <a:r>
               <a:rPr lang="en-IT" dirty="0"/>
-              <a:t>These are the target you can choose from (see </a:t>
+              <a:t>Data that you will use are collected by me using a Fitbit Versa 2</a:t>
+            </a:r>
+          </a:p>
+          <a:p>
+            <a:endParaRPr lang="en-IT" dirty="0"/>
+          </a:p>
+          <a:p>
+            <a:r>
+              <a:rPr lang="en-IT" dirty="0"/>
+              <a:t>Data are available starting from 09/02 and will be collected up </a:t>
             </a:r>
             <a:r>
               <a:rPr lang="en-IT"/>
-              <a:t>the </a:t>
-            </a:r>
-            <a:r>
-              <a:rPr lang="en-US" dirty="0" err="1"/>
-              <a:t>elearning</a:t>
+              <a:t>to 30/11</a:t>
+            </a:r>
+            <a:endParaRPr lang="en-US" dirty="0"/>
+          </a:p>
+          <a:p>
+            <a:endParaRPr lang="en-US" dirty="0"/>
+          </a:p>
+          <a:p>
+            <a:r>
+              <a:rPr lang="en-US" dirty="0"/>
+              <a:t>The following data “types” are included(see mor details in the Appendix)</a:t>
             </a:r>
             <a:r>
               <a:rPr lang="en-IT"/>
-              <a:t> </a:t>
-            </a:r>
+              <a:t>:</a:t>
+            </a:r>
+            <a:endParaRPr lang="en-IT" dirty="0"/>
+          </a:p>
+          <a:p>
+            <a:pPr lvl="1"/>
             <a:r>
               <a:rPr lang="en-IT" dirty="0"/>
-              <a:t>page for more details):</a:t>
-            </a:r>
-          </a:p>
-          <a:p>
+              <a:t>Calories</a:t>
+            </a:r>
+          </a:p>
+          <a:p>
+            <a:pPr lvl="1"/>
+            <a:r>
+              <a:rPr lang="en-IT" dirty="0"/>
+              <a:t>Distance</a:t>
+            </a:r>
+          </a:p>
+          <a:p>
+            <a:pPr lvl="1"/>
+            <a:r>
+              <a:rPr lang="en-IT" dirty="0"/>
+              <a:t>Exercise sessions</a:t>
+            </a:r>
+          </a:p>
+          <a:p>
+            <a:pPr lvl="1"/>
+            <a:r>
+              <a:rPr lang="en-IT" dirty="0"/>
+              <a:t>Heart rate</a:t>
+            </a:r>
+          </a:p>
+          <a:p>
+            <a:pPr lvl="1"/>
+            <a:r>
+              <a:rPr lang="en-IT" dirty="0"/>
+              <a:t>Resting heart rate (Estimated)</a:t>
+            </a:r>
+          </a:p>
+          <a:p>
+            <a:pPr lvl="1"/>
+            <a:r>
+              <a:rPr lang="en-IT" dirty="0"/>
+              <a:t>Sleep</a:t>
+            </a:r>
+          </a:p>
+          <a:p>
+            <a:pPr lvl="1"/>
+            <a:r>
+              <a:rPr lang="en-IT"/>
+              <a:t>Steps</a:t>
+            </a:r>
+            <a:endParaRPr lang="en-US" dirty="0"/>
+          </a:p>
+          <a:p>
+            <a:pPr lvl="1"/>
             <a:endParaRPr lang="en-IT" dirty="0"/>
           </a:p>
           <a:p>
-            <a:pPr lvl="1"/>
-            <a:r>
-              <a:rPr lang="en-GB" b="1" u="sng" dirty="0"/>
-              <a:t>SDG 2: Target 2.2</a:t>
-            </a:r>
-            <a:r>
-              <a:rPr lang="en-GB" dirty="0"/>
-              <a:t> (By 2030, end all forms of malnutrition, including achieving, by 2025, the internationally agreed targets on stunting and wasting in children under 5 years of age, and address the nutritional needs of adolescent girls, pregnant and lactating women and older persons)</a:t>
-            </a:r>
-            <a:endParaRPr lang="en-IT" dirty="0"/>
-          </a:p>
-          <a:p>
-            <a:pPr lvl="1"/>
-            <a:r>
-              <a:rPr lang="en-GB" b="1" u="sng" dirty="0"/>
-              <a:t>SDG 2: Target 2.3</a:t>
-            </a:r>
-            <a:r>
-              <a:rPr lang="en-GB" dirty="0"/>
-              <a:t> (By 2030, double the agricultural productivity and incomes of small-scale food producers, in particular women, indigenous peoples, family farmers, pastoralists and fishers, including through secure and equal access to land, other productive resources and inputs, knowledge, financial services, markets and opportunities for value addition and non-farm employment)</a:t>
-            </a:r>
-          </a:p>
-          <a:p>
-            <a:pPr lvl="1"/>
-            <a:r>
-              <a:rPr lang="en-GB" b="1" u="sng" dirty="0"/>
-              <a:t>SDG 3: Target 3.4 </a:t>
-            </a:r>
-            <a:r>
-              <a:rPr lang="en-GB" dirty="0"/>
-              <a:t>(By 2030, reduce by one third premature mortality from non-communicable diseases through prevention and treatment and promote mental health and well-being) </a:t>
-            </a:r>
-          </a:p>
-          <a:p>
-            <a:pPr lvl="1"/>
-            <a:r>
-              <a:rPr lang="en-GB" b="1" u="sng" dirty="0"/>
-              <a:t>SDG 3: Target 3.5</a:t>
-            </a:r>
-            <a:r>
-              <a:rPr lang="en-GB" dirty="0"/>
-              <a:t> (Strengthen the prevention and treatment of substance abuse, including narcotic drug abuse and harmful use of alcohol)</a:t>
-            </a:r>
-          </a:p>
-          <a:p>
-            <a:pPr lvl="1"/>
-            <a:r>
-              <a:rPr lang="en-GB" b="1" u="sng" dirty="0"/>
-              <a:t>SDG 4: Target 4.7 </a:t>
-            </a:r>
-            <a:r>
-              <a:rPr lang="en-GB" dirty="0"/>
-              <a:t>(By 2030, ensure that all learners acquire the knowledge and skills needed to promote sustainable development, including, among others, through education for sustainable development and sustainable lifestyles, human rights, gender equality, promotion of a culture of peace and non-violence, global citizenship and appreciation of cultural diversity and of culture’s contribution to sustainable development) </a:t>
-            </a:r>
-          </a:p>
-          <a:p>
-            <a:pPr lvl="1"/>
-            <a:r>
-              <a:rPr lang="en-GB" b="1" u="sng" dirty="0"/>
-              <a:t>SDG 8: Target 8.9 </a:t>
-            </a:r>
-            <a:r>
-              <a:rPr lang="en-GB" dirty="0"/>
-              <a:t>(By 2030, devise and implement policies to promote sustainable tourism that creates jobs and promotes local culture and products)</a:t>
-            </a:r>
-            <a:endParaRPr lang="en-IT" dirty="0"/>
+            <a:r>
+              <a:rPr lang="en-IT" dirty="0"/>
+              <a:t>Your project must use at least 1 type of data</a:t>
+            </a:r>
           </a:p>
         </p:txBody>
       </p:sp>
@@ -18980,221 +18419,6 @@
             <a:fld id="{31DE2C5B-556E-47B8-A792-024C2FCA4ACC}" type="slidenum">
               <a:rPr lang="en-GB" smtClean="0"/>
               <a:t>37</a:t>
-            </a:fld>
-            <a:endParaRPr lang="en-GB" dirty="0"/>
-          </a:p>
-        </p:txBody>
-      </p:sp>
-    </p:spTree>
-    <p:extLst>
-      <p:ext uri="{BB962C8B-B14F-4D97-AF65-F5344CB8AC3E}">
-        <p14:creationId xmlns:p14="http://schemas.microsoft.com/office/powerpoint/2010/main" val="4043247871"/>
-      </p:ext>
-    </p:extLst>
-  </p:cSld>
-  <p:clrMapOvr>
-    <a:masterClrMapping/>
-  </p:clrMapOvr>
-</p:sld>
-</file>
-
-<file path=ppt/slides/slide38.xml><?xml version="1.0" encoding="utf-8"?>
-<p:sld xmlns:a="http://schemas.openxmlformats.org/drawingml/2006/main" xmlns:r="http://schemas.openxmlformats.org/officeDocument/2006/relationships" xmlns:p="http://schemas.openxmlformats.org/presentationml/2006/main">
-  <p:cSld>
-    <p:spTree>
-      <p:nvGrpSpPr>
-        <p:cNvPr id="1" name=""/>
-        <p:cNvGrpSpPr/>
-        <p:nvPr/>
-      </p:nvGrpSpPr>
-      <p:grpSpPr>
-        <a:xfrm>
-          <a:off x="0" y="0"/>
-          <a:ext cx="0" cy="0"/>
-          <a:chOff x="0" y="0"/>
-          <a:chExt cx="0" cy="0"/>
-        </a:xfrm>
-      </p:grpSpPr>
-      <p:sp>
-        <p:nvSpPr>
-          <p:cNvPr id="2" name="Title 1">
-            <a:extLst>
-              <a:ext uri="{FF2B5EF4-FFF2-40B4-BE49-F238E27FC236}">
-                <a16:creationId xmlns:a16="http://schemas.microsoft.com/office/drawing/2014/main" id="{80BE60FB-C861-1E44-92E6-8F9396441CB2}"/>
-              </a:ext>
-            </a:extLst>
-          </p:cNvPr>
-          <p:cNvSpPr>
-            <a:spLocks noGrp="1"/>
-          </p:cNvSpPr>
-          <p:nvPr>
-            <p:ph type="title"/>
-          </p:nvPr>
-        </p:nvSpPr>
-        <p:spPr/>
-        <p:txBody>
-          <a:bodyPr>
-            <a:normAutofit/>
-          </a:bodyPr>
-          <a:lstStyle/>
-          <a:p>
-            <a:r>
-              <a:rPr lang="en-IT" dirty="0"/>
-              <a:t>Data source</a:t>
-            </a:r>
-          </a:p>
-        </p:txBody>
-      </p:sp>
-      <p:sp>
-        <p:nvSpPr>
-          <p:cNvPr id="3" name="Content Placeholder 2">
-            <a:extLst>
-              <a:ext uri="{FF2B5EF4-FFF2-40B4-BE49-F238E27FC236}">
-                <a16:creationId xmlns:a16="http://schemas.microsoft.com/office/drawing/2014/main" id="{ECD4BA52-23DB-D94D-9195-7777C71CD155}"/>
-              </a:ext>
-            </a:extLst>
-          </p:cNvPr>
-          <p:cNvSpPr>
-            <a:spLocks noGrp="1"/>
-          </p:cNvSpPr>
-          <p:nvPr>
-            <p:ph idx="1"/>
-          </p:nvPr>
-        </p:nvSpPr>
-        <p:spPr>
-          <a:xfrm>
-            <a:off x="428172" y="1361167"/>
-            <a:ext cx="11368314" cy="5334907"/>
-          </a:xfrm>
-        </p:spPr>
-        <p:txBody>
-          <a:bodyPr>
-            <a:normAutofit fontScale="92500" lnSpcReduction="10000"/>
-          </a:bodyPr>
-          <a:lstStyle/>
-          <a:p>
-            <a:endParaRPr lang="en-IT" dirty="0"/>
-          </a:p>
-          <a:p>
-            <a:r>
-              <a:rPr lang="en-IT" dirty="0"/>
-              <a:t>Data that you will use are collected by me using a Fitbit Versa 2</a:t>
-            </a:r>
-          </a:p>
-          <a:p>
-            <a:endParaRPr lang="en-IT" dirty="0"/>
-          </a:p>
-          <a:p>
-            <a:r>
-              <a:rPr lang="en-IT" dirty="0"/>
-              <a:t>Data are available starting from 09/02 and will be collected up </a:t>
-            </a:r>
-            <a:r>
-              <a:rPr lang="en-IT"/>
-              <a:t>to 30/11</a:t>
-            </a:r>
-            <a:endParaRPr lang="en-US" dirty="0"/>
-          </a:p>
-          <a:p>
-            <a:endParaRPr lang="en-US" dirty="0"/>
-          </a:p>
-          <a:p>
-            <a:r>
-              <a:rPr lang="en-US" dirty="0"/>
-              <a:t>The following data “types” are included(see mor details in the Appendix)</a:t>
-            </a:r>
-            <a:r>
-              <a:rPr lang="en-IT"/>
-              <a:t>:</a:t>
-            </a:r>
-            <a:endParaRPr lang="en-IT" dirty="0"/>
-          </a:p>
-          <a:p>
-            <a:pPr lvl="1"/>
-            <a:r>
-              <a:rPr lang="en-IT" dirty="0"/>
-              <a:t>Calories</a:t>
-            </a:r>
-          </a:p>
-          <a:p>
-            <a:pPr lvl="1"/>
-            <a:r>
-              <a:rPr lang="en-IT" dirty="0"/>
-              <a:t>Distance</a:t>
-            </a:r>
-          </a:p>
-          <a:p>
-            <a:pPr lvl="1"/>
-            <a:r>
-              <a:rPr lang="en-IT" dirty="0"/>
-              <a:t>Exercise sessions</a:t>
-            </a:r>
-          </a:p>
-          <a:p>
-            <a:pPr lvl="1"/>
-            <a:r>
-              <a:rPr lang="en-IT" dirty="0"/>
-              <a:t>Heart rate</a:t>
-            </a:r>
-          </a:p>
-          <a:p>
-            <a:pPr lvl="1"/>
-            <a:r>
-              <a:rPr lang="en-IT" dirty="0"/>
-              <a:t>Resting heart rate (Estimated)</a:t>
-            </a:r>
-          </a:p>
-          <a:p>
-            <a:pPr lvl="1"/>
-            <a:r>
-              <a:rPr lang="en-IT" dirty="0"/>
-              <a:t>Sleep</a:t>
-            </a:r>
-          </a:p>
-          <a:p>
-            <a:pPr lvl="1"/>
-            <a:r>
-              <a:rPr lang="en-IT"/>
-              <a:t>Steps</a:t>
-            </a:r>
-            <a:endParaRPr lang="en-US" dirty="0"/>
-          </a:p>
-          <a:p>
-            <a:pPr lvl="1"/>
-            <a:endParaRPr lang="en-IT" dirty="0"/>
-          </a:p>
-          <a:p>
-            <a:r>
-              <a:rPr lang="en-IT" dirty="0"/>
-              <a:t>Your project must use at least 1 type of data</a:t>
-            </a:r>
-          </a:p>
-        </p:txBody>
-      </p:sp>
-      <p:sp>
-        <p:nvSpPr>
-          <p:cNvPr id="4" name="Slide Number Placeholder 3">
-            <a:extLst>
-              <a:ext uri="{FF2B5EF4-FFF2-40B4-BE49-F238E27FC236}">
-                <a16:creationId xmlns:a16="http://schemas.microsoft.com/office/drawing/2014/main" id="{C57ACF48-43BD-9049-83DA-4C0AF0AC5D28}"/>
-              </a:ext>
-            </a:extLst>
-          </p:cNvPr>
-          <p:cNvSpPr>
-            <a:spLocks noGrp="1"/>
-          </p:cNvSpPr>
-          <p:nvPr>
-            <p:ph type="sldNum" sz="quarter" idx="12"/>
-          </p:nvPr>
-        </p:nvSpPr>
-        <p:spPr/>
-        <p:txBody>
-          <a:bodyPr/>
-          <a:lstStyle/>
-          <a:p>
-            <a:fld id="{31DE2C5B-556E-47B8-A792-024C2FCA4ACC}" type="slidenum">
-              <a:rPr lang="en-GB" smtClean="0"/>
-              <a:t>38</a:t>
             </a:fld>
             <a:endParaRPr lang="en-GB" dirty="0"/>
           </a:p>
@@ -19243,7 +18467,7 @@
 </p:sld>
 </file>
 
-<file path=ppt/slides/slide39.xml><?xml version="1.0" encoding="utf-8"?>
+<file path=ppt/slides/slide38.xml><?xml version="1.0" encoding="utf-8"?>
 <p:sld xmlns:a="http://schemas.openxmlformats.org/drawingml/2006/main" xmlns:r="http://schemas.openxmlformats.org/officeDocument/2006/relationships" xmlns:p="http://schemas.openxmlformats.org/presentationml/2006/main">
   <p:cSld>
     <p:spTree>
@@ -19313,7 +18537,7 @@
           <a:p>
             <a:fld id="{31DE2C5B-556E-47B8-A792-024C2FCA4ACC}" type="slidenum">
               <a:rPr lang="en-GB" smtClean="0"/>
-              <a:t>39</a:t>
+              <a:t>38</a:t>
             </a:fld>
             <a:endParaRPr lang="en-GB" dirty="0"/>
           </a:p>
@@ -20466,6 +19690,600 @@
     <p:extLst>
       <p:ext uri="{BB962C8B-B14F-4D97-AF65-F5344CB8AC3E}">
         <p14:creationId xmlns:p14="http://schemas.microsoft.com/office/powerpoint/2010/main" val="1807656441"/>
+      </p:ext>
+    </p:extLst>
+  </p:cSld>
+  <p:clrMapOvr>
+    <a:masterClrMapping/>
+  </p:clrMapOvr>
+</p:sld>
+</file>
+
+<file path=ppt/slides/slide39.xml><?xml version="1.0" encoding="utf-8"?>
+<p:sld xmlns:a="http://schemas.openxmlformats.org/drawingml/2006/main" xmlns:r="http://schemas.openxmlformats.org/officeDocument/2006/relationships" xmlns:p="http://schemas.openxmlformats.org/presentationml/2006/main">
+  <p:cSld>
+    <p:spTree>
+      <p:nvGrpSpPr>
+        <p:cNvPr id="1" name=""/>
+        <p:cNvGrpSpPr/>
+        <p:nvPr/>
+      </p:nvGrpSpPr>
+      <p:grpSpPr>
+        <a:xfrm>
+          <a:off x="0" y="0"/>
+          <a:ext cx="0" cy="0"/>
+          <a:chOff x="0" y="0"/>
+          <a:chExt cx="0" cy="0"/>
+        </a:xfrm>
+      </p:grpSpPr>
+      <p:sp>
+        <p:nvSpPr>
+          <p:cNvPr id="2" name="Titolo 1"/>
+          <p:cNvSpPr>
+            <a:spLocks noGrp="1"/>
+          </p:cNvSpPr>
+          <p:nvPr>
+            <p:ph type="title"/>
+          </p:nvPr>
+        </p:nvSpPr>
+        <p:spPr/>
+        <p:txBody>
+          <a:bodyPr/>
+          <a:lstStyle/>
+          <a:p>
+            <a:r>
+              <a:rPr lang="it-IT" dirty="0"/>
+              <a:t>Optional tutoring activities</a:t>
+            </a:r>
+            <a:endParaRPr lang="en-GB" dirty="0"/>
+          </a:p>
+        </p:txBody>
+      </p:sp>
+      <p:sp>
+        <p:nvSpPr>
+          <p:cNvPr id="3" name="Segnaposto contenuto 2"/>
+          <p:cNvSpPr>
+            <a:spLocks noGrp="1"/>
+          </p:cNvSpPr>
+          <p:nvPr>
+            <p:ph idx="1"/>
+          </p:nvPr>
+        </p:nvSpPr>
+        <p:spPr>
+          <a:xfrm>
+            <a:off x="428170" y="1361166"/>
+            <a:ext cx="11763829" cy="618539"/>
+          </a:xfrm>
+        </p:spPr>
+        <p:txBody>
+          <a:bodyPr>
+            <a:normAutofit fontScale="92500"/>
+          </a:bodyPr>
+          <a:lstStyle/>
+          <a:p>
+            <a:r>
+              <a:rPr lang="en-US" dirty="0"/>
+              <a:t>Need help? They are here to cover your back with answers and optional tutoring activities</a:t>
+            </a:r>
+          </a:p>
+        </p:txBody>
+      </p:sp>
+      <p:sp>
+        <p:nvSpPr>
+          <p:cNvPr id="5" name="Rettangolo 4"/>
+          <p:cNvSpPr/>
+          <p:nvPr/>
+        </p:nvSpPr>
+        <p:spPr>
+          <a:xfrm>
+            <a:off x="5486400" y="2195566"/>
+            <a:ext cx="6585857" cy="2638236"/>
+          </a:xfrm>
+          <a:prstGeom prst="rect">
+            <a:avLst/>
+          </a:prstGeom>
+          <a:ln w="57150">
+            <a:solidFill>
+              <a:srgbClr val="00B050"/>
+            </a:solidFill>
+          </a:ln>
+        </p:spPr>
+        <p:style>
+          <a:lnRef idx="2">
+            <a:schemeClr val="accent6"/>
+          </a:lnRef>
+          <a:fillRef idx="1">
+            <a:schemeClr val="lt1"/>
+          </a:fillRef>
+          <a:effectRef idx="0">
+            <a:schemeClr val="accent6"/>
+          </a:effectRef>
+          <a:fontRef idx="minor">
+            <a:schemeClr val="dk1"/>
+          </a:fontRef>
+        </p:style>
+        <p:txBody>
+          <a:bodyPr rtlCol="0" anchor="t"/>
+          <a:lstStyle/>
+          <a:p>
+            <a:pPr algn="ctr"/>
+            <a:r>
+              <a:rPr lang="en-GB" b="1" dirty="0">
+                <a:latin typeface="Aptos" panose="020B0004020202020204" pitchFamily="34" charset="0"/>
+              </a:rPr>
+              <a:t>Calendar of the optional tutoring activities</a:t>
+            </a:r>
+          </a:p>
+          <a:p>
+            <a:pPr algn="ctr"/>
+            <a:endParaRPr lang="en-GB" dirty="0">
+              <a:latin typeface="Aptos" panose="020B0004020202020204" pitchFamily="34" charset="0"/>
+            </a:endParaRPr>
+          </a:p>
+        </p:txBody>
+      </p:sp>
+      <p:sp>
+        <p:nvSpPr>
+          <p:cNvPr id="6" name="Segnaposto numero diapositiva 5"/>
+          <p:cNvSpPr>
+            <a:spLocks noGrp="1"/>
+          </p:cNvSpPr>
+          <p:nvPr>
+            <p:ph type="sldNum" sz="quarter" idx="12"/>
+          </p:nvPr>
+        </p:nvSpPr>
+        <p:spPr/>
+        <p:txBody>
+          <a:bodyPr/>
+          <a:lstStyle/>
+          <a:p>
+            <a:fld id="{31DE2C5B-556E-47B8-A792-024C2FCA4ACC}" type="slidenum">
+              <a:rPr lang="en-GB" smtClean="0"/>
+              <a:t>39</a:t>
+            </a:fld>
+            <a:endParaRPr lang="en-GB" dirty="0"/>
+          </a:p>
+        </p:txBody>
+      </p:sp>
+      <p:pic>
+        <p:nvPicPr>
+          <p:cNvPr id="4" name="Google Shape;98;p9" descr="Immagine che contiene Viso umano, persona, Fronte, Mento&#10;&#10;Descrizione generata automaticamente">
+            <a:extLst>
+              <a:ext uri="{FF2B5EF4-FFF2-40B4-BE49-F238E27FC236}">
+                <a16:creationId xmlns:a16="http://schemas.microsoft.com/office/drawing/2014/main" id="{C73A1938-85C6-DC14-C277-6C82B5875B84}"/>
+              </a:ext>
+            </a:extLst>
+          </p:cNvPr>
+          <p:cNvPicPr preferRelativeResize="0">
+            <a:picLocks noChangeAspect="1"/>
+          </p:cNvPicPr>
+          <p:nvPr/>
+        </p:nvPicPr>
+        <p:blipFill rotWithShape="1">
+          <a:blip r:embed="rId2">
+            <a:alphaModFix/>
+          </a:blip>
+          <a:srcRect t="-517"/>
+          <a:stretch/>
+        </p:blipFill>
+        <p:spPr>
+          <a:xfrm>
+            <a:off x="428172" y="2149203"/>
+            <a:ext cx="1659658" cy="1985014"/>
+          </a:xfrm>
+          <a:prstGeom prst="rect">
+            <a:avLst/>
+          </a:prstGeom>
+          <a:noFill/>
+          <a:ln>
+            <a:noFill/>
+          </a:ln>
+        </p:spPr>
+      </p:pic>
+      <p:sp>
+        <p:nvSpPr>
+          <p:cNvPr id="8" name="Segnaposto contenuto 2">
+            <a:extLst>
+              <a:ext uri="{FF2B5EF4-FFF2-40B4-BE49-F238E27FC236}">
+                <a16:creationId xmlns:a16="http://schemas.microsoft.com/office/drawing/2014/main" id="{702BA522-6E01-F8A9-9985-C031C76C2B43}"/>
+              </a:ext>
+            </a:extLst>
+          </p:cNvPr>
+          <p:cNvSpPr txBox="1">
+            <a:spLocks/>
+          </p:cNvSpPr>
+          <p:nvPr/>
+        </p:nvSpPr>
+        <p:spPr>
+          <a:xfrm>
+            <a:off x="2190045" y="2996119"/>
+            <a:ext cx="7197083" cy="3518303"/>
+          </a:xfrm>
+          <a:prstGeom prst="rect">
+            <a:avLst/>
+          </a:prstGeom>
+        </p:spPr>
+        <p:txBody>
+          <a:bodyPr vert="horz" lIns="91440" tIns="45720" rIns="91440" bIns="45720" rtlCol="0">
+            <a:normAutofit/>
+          </a:bodyPr>
+          <a:lstStyle>
+            <a:lvl1pPr marL="342900" indent="-342900" algn="l" defTabSz="914400" rtl="0" eaLnBrk="1" latinLnBrk="0" hangingPunct="1">
+              <a:lnSpc>
+                <a:spcPct val="90000"/>
+              </a:lnSpc>
+              <a:spcBef>
+                <a:spcPts val="1000"/>
+              </a:spcBef>
+              <a:buClr>
+                <a:srgbClr val="00B050"/>
+              </a:buClr>
+              <a:buFont typeface="Wingdings" panose="05000000000000000000" pitchFamily="2" charset="2"/>
+              <a:buChar char="Ø"/>
+              <a:defRPr sz="2400" kern="1200">
+                <a:solidFill>
+                  <a:schemeClr val="tx1"/>
+                </a:solidFill>
+                <a:latin typeface="Palatino Linotype" panose="02040502050505030304" pitchFamily="18" charset="0"/>
+                <a:ea typeface="+mn-ea"/>
+                <a:cs typeface="+mn-cs"/>
+              </a:defRPr>
+            </a:lvl1pPr>
+            <a:lvl2pPr marL="685800" indent="-228600" algn="l" defTabSz="914400" rtl="0" eaLnBrk="1" latinLnBrk="0" hangingPunct="1">
+              <a:lnSpc>
+                <a:spcPct val="90000"/>
+              </a:lnSpc>
+              <a:spcBef>
+                <a:spcPts val="500"/>
+              </a:spcBef>
+              <a:buClr>
+                <a:srgbClr val="00B050"/>
+              </a:buClr>
+              <a:buFont typeface="Wingdings" panose="05000000000000000000" pitchFamily="2" charset="2"/>
+              <a:buChar char="§"/>
+              <a:defRPr sz="2000" kern="1200">
+                <a:solidFill>
+                  <a:schemeClr val="tx1"/>
+                </a:solidFill>
+                <a:latin typeface="Palatino Linotype" panose="02040502050505030304" pitchFamily="18" charset="0"/>
+                <a:ea typeface="+mn-ea"/>
+                <a:cs typeface="+mn-cs"/>
+              </a:defRPr>
+            </a:lvl2pPr>
+            <a:lvl3pPr marL="1143000" indent="-228600" algn="l" defTabSz="914400" rtl="0" eaLnBrk="1" latinLnBrk="0" hangingPunct="1">
+              <a:lnSpc>
+                <a:spcPct val="90000"/>
+              </a:lnSpc>
+              <a:spcBef>
+                <a:spcPts val="500"/>
+              </a:spcBef>
+              <a:buClr>
+                <a:srgbClr val="00B050"/>
+              </a:buClr>
+              <a:buFont typeface="Arial" panose="020B0604020202020204" pitchFamily="34" charset="0"/>
+              <a:buChar char="•"/>
+              <a:defRPr sz="1800" kern="1200">
+                <a:solidFill>
+                  <a:schemeClr val="tx1"/>
+                </a:solidFill>
+                <a:latin typeface="Palatino Linotype" panose="02040502050505030304" pitchFamily="18" charset="0"/>
+                <a:ea typeface="+mn-ea"/>
+                <a:cs typeface="+mn-cs"/>
+              </a:defRPr>
+            </a:lvl3pPr>
+            <a:lvl4pPr marL="1600200" indent="-228600" algn="l" defTabSz="914400" rtl="0" eaLnBrk="1" latinLnBrk="0" hangingPunct="1">
+              <a:lnSpc>
+                <a:spcPct val="90000"/>
+              </a:lnSpc>
+              <a:spcBef>
+                <a:spcPts val="500"/>
+              </a:spcBef>
+              <a:buClr>
+                <a:srgbClr val="00B050"/>
+              </a:buClr>
+              <a:buFont typeface="Courier New" panose="02070309020205020404" pitchFamily="49" charset="0"/>
+              <a:buChar char="o"/>
+              <a:defRPr sz="1600" kern="1200">
+                <a:solidFill>
+                  <a:schemeClr val="tx1"/>
+                </a:solidFill>
+                <a:latin typeface="Palatino Linotype" panose="02040502050505030304" pitchFamily="18" charset="0"/>
+                <a:ea typeface="+mn-ea"/>
+                <a:cs typeface="+mn-cs"/>
+              </a:defRPr>
+            </a:lvl4pPr>
+            <a:lvl5pPr marL="2057400" indent="-228600" algn="l" defTabSz="914400" rtl="0" eaLnBrk="1" latinLnBrk="0" hangingPunct="1">
+              <a:lnSpc>
+                <a:spcPct val="90000"/>
+              </a:lnSpc>
+              <a:spcBef>
+                <a:spcPts val="500"/>
+              </a:spcBef>
+              <a:buClr>
+                <a:srgbClr val="00B050"/>
+              </a:buClr>
+              <a:buFont typeface="Times New Roman" panose="02020603050405020304" pitchFamily="18" charset="0"/>
+              <a:buChar char="̶"/>
+              <a:defRPr sz="1600" kern="1200">
+                <a:solidFill>
+                  <a:schemeClr val="tx1"/>
+                </a:solidFill>
+                <a:latin typeface="Palatino Linotype" panose="02040502050505030304" pitchFamily="18" charset="0"/>
+                <a:ea typeface="+mn-ea"/>
+                <a:cs typeface="+mn-cs"/>
+              </a:defRPr>
+            </a:lvl5pPr>
+            <a:lvl6pPr marL="2514600" indent="-228600" algn="l" defTabSz="914400" rtl="0" eaLnBrk="1" latinLnBrk="0" hangingPunct="1">
+              <a:lnSpc>
+                <a:spcPct val="90000"/>
+              </a:lnSpc>
+              <a:spcBef>
+                <a:spcPts val="500"/>
+              </a:spcBef>
+              <a:buFont typeface="Arial" panose="020B0604020202020204" pitchFamily="34" charset="0"/>
+              <a:buChar char="•"/>
+              <a:defRPr sz="1800" kern="1200">
+                <a:solidFill>
+                  <a:schemeClr val="tx1"/>
+                </a:solidFill>
+                <a:latin typeface="+mn-lt"/>
+                <a:ea typeface="+mn-ea"/>
+                <a:cs typeface="+mn-cs"/>
+              </a:defRPr>
+            </a:lvl6pPr>
+            <a:lvl7pPr marL="2971800" indent="-228600" algn="l" defTabSz="914400" rtl="0" eaLnBrk="1" latinLnBrk="0" hangingPunct="1">
+              <a:lnSpc>
+                <a:spcPct val="90000"/>
+              </a:lnSpc>
+              <a:spcBef>
+                <a:spcPts val="500"/>
+              </a:spcBef>
+              <a:buFont typeface="Arial" panose="020B0604020202020204" pitchFamily="34" charset="0"/>
+              <a:buChar char="•"/>
+              <a:defRPr sz="1800" kern="1200">
+                <a:solidFill>
+                  <a:schemeClr val="tx1"/>
+                </a:solidFill>
+                <a:latin typeface="+mn-lt"/>
+                <a:ea typeface="+mn-ea"/>
+                <a:cs typeface="+mn-cs"/>
+              </a:defRPr>
+            </a:lvl7pPr>
+            <a:lvl8pPr marL="3429000" indent="-228600" algn="l" defTabSz="914400" rtl="0" eaLnBrk="1" latinLnBrk="0" hangingPunct="1">
+              <a:lnSpc>
+                <a:spcPct val="90000"/>
+              </a:lnSpc>
+              <a:spcBef>
+                <a:spcPts val="500"/>
+              </a:spcBef>
+              <a:buFont typeface="Arial" panose="020B0604020202020204" pitchFamily="34" charset="0"/>
+              <a:buChar char="•"/>
+              <a:defRPr sz="1800" kern="1200">
+                <a:solidFill>
+                  <a:schemeClr val="tx1"/>
+                </a:solidFill>
+                <a:latin typeface="+mn-lt"/>
+                <a:ea typeface="+mn-ea"/>
+                <a:cs typeface="+mn-cs"/>
+              </a:defRPr>
+            </a:lvl8pPr>
+            <a:lvl9pPr marL="3886200" indent="-228600" algn="l" defTabSz="914400" rtl="0" eaLnBrk="1" latinLnBrk="0" hangingPunct="1">
+              <a:lnSpc>
+                <a:spcPct val="90000"/>
+              </a:lnSpc>
+              <a:spcBef>
+                <a:spcPts val="500"/>
+              </a:spcBef>
+              <a:buFont typeface="Arial" panose="020B0604020202020204" pitchFamily="34" charset="0"/>
+              <a:buChar char="•"/>
+              <a:defRPr sz="1800" kern="1200">
+                <a:solidFill>
+                  <a:schemeClr val="tx1"/>
+                </a:solidFill>
+                <a:latin typeface="+mn-lt"/>
+                <a:ea typeface="+mn-ea"/>
+                <a:cs typeface="+mn-cs"/>
+              </a:defRPr>
+            </a:lvl9pPr>
+          </a:lstStyle>
+          <a:p>
+            <a:r>
+              <a:rPr lang="en-US" sz="1800" dirty="0">
+                <a:latin typeface="Aptos" panose="020B0004020202020204" pitchFamily="34" charset="0"/>
+              </a:rPr>
+              <a:t>Luca Cossu</a:t>
+            </a:r>
+          </a:p>
+          <a:p>
+            <a:pPr marL="0" indent="0">
+              <a:buNone/>
+            </a:pPr>
+            <a:r>
+              <a:rPr lang="en-US" sz="1800" dirty="0">
+                <a:solidFill>
+                  <a:srgbClr val="C00000"/>
+                </a:solidFill>
+                <a:latin typeface="Aptos" panose="020B0004020202020204" pitchFamily="34" charset="0"/>
+                <a:hlinkClick r:id="rId3">
+                  <a:extLst>
+                    <a:ext uri="{A12FA001-AC4F-418D-AE19-62706E023703}">
+                      <ahyp:hlinkClr xmlns:ahyp="http://schemas.microsoft.com/office/drawing/2018/hyperlinkcolor" val="tx"/>
+                    </a:ext>
+                  </a:extLst>
+                </a:hlinkClick>
+              </a:rPr>
+              <a:t>luca.cossu@phd.unipd.it</a:t>
+            </a:r>
+            <a:r>
+              <a:rPr lang="en-US" sz="1800" dirty="0">
+                <a:solidFill>
+                  <a:srgbClr val="C00000"/>
+                </a:solidFill>
+                <a:latin typeface="Aptos" panose="020B0004020202020204" pitchFamily="34" charset="0"/>
+              </a:rPr>
+              <a:t> </a:t>
+            </a:r>
+          </a:p>
+          <a:p>
+            <a:endParaRPr lang="en-US" sz="1800" dirty="0">
+              <a:latin typeface="Aptos" panose="020B0004020202020204" pitchFamily="34" charset="0"/>
+            </a:endParaRPr>
+          </a:p>
+          <a:p>
+            <a:endParaRPr lang="en-US" sz="1800" dirty="0">
+              <a:latin typeface="Aptos" panose="020B0004020202020204" pitchFamily="34" charset="0"/>
+            </a:endParaRPr>
+          </a:p>
+          <a:p>
+            <a:endParaRPr lang="en-US" sz="1800" dirty="0">
+              <a:latin typeface="Aptos" panose="020B0004020202020204" pitchFamily="34" charset="0"/>
+            </a:endParaRPr>
+          </a:p>
+          <a:p>
+            <a:r>
+              <a:rPr lang="en-US" sz="1800" dirty="0">
+                <a:latin typeface="Aptos" panose="020B0004020202020204" pitchFamily="34" charset="0"/>
+              </a:rPr>
+              <a:t>Alberto </a:t>
+            </a:r>
+            <a:r>
+              <a:rPr lang="en-US" sz="1800" dirty="0" err="1">
+                <a:latin typeface="Aptos" panose="020B0004020202020204" pitchFamily="34" charset="0"/>
+              </a:rPr>
+              <a:t>Gastaldello</a:t>
+            </a:r>
+            <a:endParaRPr lang="en-US" sz="1800" dirty="0">
+              <a:solidFill>
+                <a:srgbClr val="C00000"/>
+              </a:solidFill>
+              <a:latin typeface="Aptos" panose="020B0004020202020204" pitchFamily="34" charset="0"/>
+            </a:endParaRPr>
+          </a:p>
+          <a:p>
+            <a:pPr marL="0" indent="0">
+              <a:buNone/>
+            </a:pPr>
+            <a:r>
+              <a:rPr lang="en-US" sz="1800" dirty="0">
+                <a:solidFill>
+                  <a:srgbClr val="C00000"/>
+                </a:solidFill>
+                <a:latin typeface="Aptos" panose="020B0004020202020204" pitchFamily="34" charset="0"/>
+                <a:hlinkClick r:id="rId4">
+                  <a:extLst>
+                    <a:ext uri="{A12FA001-AC4F-418D-AE19-62706E023703}">
+                      <ahyp:hlinkClr xmlns:ahyp="http://schemas.microsoft.com/office/drawing/2018/hyperlinkcolor" val="tx"/>
+                    </a:ext>
+                  </a:extLst>
+                </a:hlinkClick>
+              </a:rPr>
+              <a:t>alberto.gastaldello.2@phd.unipd.it</a:t>
+            </a:r>
+            <a:r>
+              <a:rPr lang="en-US" sz="1800" dirty="0">
+                <a:solidFill>
+                  <a:srgbClr val="C00000"/>
+                </a:solidFill>
+                <a:latin typeface="Aptos" panose="020B0004020202020204" pitchFamily="34" charset="0"/>
+              </a:rPr>
+              <a:t> </a:t>
+            </a:r>
+            <a:br>
+              <a:rPr lang="en-US" sz="1800" dirty="0">
+                <a:latin typeface="Aptos" panose="020B0004020202020204" pitchFamily="34" charset="0"/>
+              </a:rPr>
+            </a:br>
+            <a:endParaRPr lang="en-US" sz="1800" dirty="0">
+              <a:latin typeface="Aptos" panose="020B0004020202020204" pitchFamily="34" charset="0"/>
+            </a:endParaRPr>
+          </a:p>
+          <a:p>
+            <a:endParaRPr lang="en-US" sz="1800" dirty="0">
+              <a:latin typeface="Aptos" panose="020B0004020202020204" pitchFamily="34" charset="0"/>
+            </a:endParaRPr>
+          </a:p>
+          <a:p>
+            <a:endParaRPr lang="en-US" sz="1800" dirty="0">
+              <a:latin typeface="Aptos" panose="020B0004020202020204" pitchFamily="34" charset="0"/>
+            </a:endParaRPr>
+          </a:p>
+        </p:txBody>
+      </p:sp>
+      <p:pic>
+        <p:nvPicPr>
+          <p:cNvPr id="13" name="Picture 12" descr="A person wearing glasses and a blue jacket&#10;&#10;AI-generated content may be incorrect.">
+            <a:extLst>
+              <a:ext uri="{FF2B5EF4-FFF2-40B4-BE49-F238E27FC236}">
+                <a16:creationId xmlns:a16="http://schemas.microsoft.com/office/drawing/2014/main" id="{988E4DF5-823B-DB3E-BE13-A68FBC5CC80A}"/>
+              </a:ext>
+            </a:extLst>
+          </p:cNvPr>
+          <p:cNvPicPr>
+            <a:picLocks noChangeAspect="1"/>
+          </p:cNvPicPr>
+          <p:nvPr/>
+        </p:nvPicPr>
+        <p:blipFill>
+          <a:blip r:embed="rId5">
+            <a:extLst>
+              <a:ext uri="{28A0092B-C50C-407E-A947-70E740481C1C}">
+                <a14:useLocalDpi xmlns:a14="http://schemas.microsoft.com/office/drawing/2010/main" val="0"/>
+              </a:ext>
+            </a:extLst>
+          </a:blip>
+          <a:srcRect l="20234" t="7515" r="17055" b="32838"/>
+          <a:stretch/>
+        </p:blipFill>
+        <p:spPr>
+          <a:xfrm>
+            <a:off x="428169" y="4347633"/>
+            <a:ext cx="1663677" cy="1656714"/>
+          </a:xfrm>
+          <a:prstGeom prst="rect">
+            <a:avLst/>
+          </a:prstGeom>
+        </p:spPr>
+      </p:pic>
+      <p:pic>
+        <p:nvPicPr>
+          <p:cNvPr id="9" name="Picture 8" descr="A table with text on it&#10;&#10;AI-generated content may be incorrect.">
+            <a:extLst>
+              <a:ext uri="{FF2B5EF4-FFF2-40B4-BE49-F238E27FC236}">
+                <a16:creationId xmlns:a16="http://schemas.microsoft.com/office/drawing/2014/main" id="{7447DC5E-6376-B627-E750-1F8578585271}"/>
+              </a:ext>
+            </a:extLst>
+          </p:cNvPr>
+          <p:cNvPicPr>
+            <a:picLocks noChangeAspect="1"/>
+          </p:cNvPicPr>
+          <p:nvPr/>
+        </p:nvPicPr>
+        <p:blipFill>
+          <a:blip r:embed="rId6">
+            <a:extLst>
+              <a:ext uri="{28A0092B-C50C-407E-A947-70E740481C1C}">
+                <a14:useLocalDpi xmlns:a14="http://schemas.microsoft.com/office/drawing/2010/main" val="0"/>
+              </a:ext>
+            </a:extLst>
+          </a:blip>
+          <a:stretch>
+            <a:fillRect/>
+          </a:stretch>
+        </p:blipFill>
+        <p:spPr>
+          <a:xfrm>
+            <a:off x="5599127" y="2631395"/>
+            <a:ext cx="6346438" cy="1989364"/>
+          </a:xfrm>
+          <a:prstGeom prst="rect">
+            <a:avLst/>
+          </a:prstGeom>
+        </p:spPr>
+      </p:pic>
+    </p:spTree>
+    <p:extLst>
+      <p:ext uri="{BB962C8B-B14F-4D97-AF65-F5344CB8AC3E}">
+        <p14:creationId xmlns:p14="http://schemas.microsoft.com/office/powerpoint/2010/main" val="3733545451"/>
       </p:ext>
     </p:extLst>
   </p:cSld>
@@ -21351,8 +21169,12 @@
           <a:lstStyle/>
           <a:p>
             <a:r>
+              <a:rPr lang="it-IT" dirty="0" err="1"/>
+              <a:t>Discord</a:t>
+            </a:r>
+            <a:r>
               <a:rPr lang="it-IT" dirty="0"/>
-              <a:t>Optional tutoring activities</a:t>
+              <a:t> server</a:t>
             </a:r>
             <a:endParaRPr lang="en-GB" dirty="0"/>
           </a:p>
@@ -21370,74 +21192,53 @@
         </p:nvSpPr>
         <p:spPr>
           <a:xfrm>
-            <a:off x="428170" y="1361166"/>
-            <a:ext cx="11763829" cy="618539"/>
+            <a:off x="428172" y="4078014"/>
+            <a:ext cx="11368314" cy="2525986"/>
           </a:xfrm>
         </p:spPr>
         <p:txBody>
           <a:bodyPr>
-            <a:normAutofit fontScale="92500"/>
+            <a:normAutofit/>
           </a:bodyPr>
           <a:lstStyle/>
           <a:p>
             <a:r>
               <a:rPr lang="en-US" dirty="0"/>
-              <a:t>Need help? They are here to cover your back with answers and optional tutoring activities</a:t>
-            </a:r>
-          </a:p>
-        </p:txBody>
-      </p:sp>
-      <p:sp>
-        <p:nvSpPr>
-          <p:cNvPr id="5" name="Rettangolo 4"/>
-          <p:cNvSpPr/>
-          <p:nvPr/>
-        </p:nvSpPr>
-        <p:spPr>
-          <a:xfrm>
-            <a:off x="5486400" y="2195566"/>
-            <a:ext cx="6585857" cy="2638236"/>
-          </a:xfrm>
-          <a:prstGeom prst="rect">
-            <a:avLst/>
-          </a:prstGeom>
-          <a:ln w="57150">
-            <a:solidFill>
-              <a:srgbClr val="00B050"/>
-            </a:solidFill>
-          </a:ln>
-        </p:spPr>
-        <p:style>
-          <a:lnRef idx="2">
-            <a:schemeClr val="accent6"/>
-          </a:lnRef>
-          <a:fillRef idx="1">
-            <a:schemeClr val="lt1"/>
-          </a:fillRef>
-          <a:effectRef idx="0">
-            <a:schemeClr val="accent6"/>
-          </a:effectRef>
-          <a:fontRef idx="minor">
-            <a:schemeClr val="dk1"/>
-          </a:fontRef>
-        </p:style>
-        <p:txBody>
-          <a:bodyPr rtlCol="0" anchor="t"/>
-          <a:lstStyle/>
-          <a:p>
-            <a:pPr algn="ctr"/>
-            <a:r>
-              <a:rPr lang="en-GB" b="1" dirty="0">
-                <a:latin typeface="Aptos" panose="020B0004020202020204" pitchFamily="34" charset="0"/>
-              </a:rPr>
-              <a:t>Calendar of the optional tutoring activities</a:t>
-            </a:r>
-          </a:p>
-          <a:p>
-            <a:pPr algn="ctr"/>
-            <a:endParaRPr lang="en-GB" dirty="0">
-              <a:latin typeface="Aptos" panose="020B0004020202020204" pitchFamily="34" charset="0"/>
-            </a:endParaRPr>
+              <a:t>Join the Discord server to get in touch and ask questions</a:t>
+            </a:r>
+          </a:p>
+          <a:p>
+            <a:endParaRPr lang="en-US" dirty="0"/>
+          </a:p>
+          <a:p>
+            <a:r>
+              <a:rPr lang="en-US" b="1" dirty="0"/>
+              <a:t>Link: </a:t>
+            </a:r>
+            <a:r>
+              <a:rPr lang="en-US" b="1" dirty="0">
+                <a:solidFill>
+                  <a:srgbClr val="C00000"/>
+                </a:solidFill>
+              </a:rPr>
+              <a:t>https://</a:t>
+            </a:r>
+            <a:r>
+              <a:rPr lang="en-US" b="1" dirty="0" err="1">
+                <a:solidFill>
+                  <a:srgbClr val="C00000"/>
+                </a:solidFill>
+              </a:rPr>
+              <a:t>discord.gg</a:t>
+            </a:r>
+            <a:r>
+              <a:rPr lang="en-US" b="1" dirty="0">
+                <a:solidFill>
+                  <a:srgbClr val="C00000"/>
+                </a:solidFill>
+              </a:rPr>
+              <a:t>/j76A3D27bm</a:t>
+            </a:r>
           </a:p>
         </p:txBody>
       </p:sp>
@@ -21459,583 +21260,6 @@
             <a:fld id="{31DE2C5B-556E-47B8-A792-024C2FCA4ACC}" type="slidenum">
               <a:rPr lang="en-GB" smtClean="0"/>
               <a:t>40</a:t>
-            </a:fld>
-            <a:endParaRPr lang="en-GB" dirty="0"/>
-          </a:p>
-        </p:txBody>
-      </p:sp>
-      <p:pic>
-        <p:nvPicPr>
-          <p:cNvPr id="4" name="Google Shape;98;p9" descr="Immagine che contiene Viso umano, persona, Fronte, Mento&#10;&#10;Descrizione generata automaticamente">
-            <a:extLst>
-              <a:ext uri="{FF2B5EF4-FFF2-40B4-BE49-F238E27FC236}">
-                <a16:creationId xmlns:a16="http://schemas.microsoft.com/office/drawing/2014/main" id="{C73A1938-85C6-DC14-C277-6C82B5875B84}"/>
-              </a:ext>
-            </a:extLst>
-          </p:cNvPr>
-          <p:cNvPicPr preferRelativeResize="0">
-            <a:picLocks noChangeAspect="1"/>
-          </p:cNvPicPr>
-          <p:nvPr/>
-        </p:nvPicPr>
-        <p:blipFill rotWithShape="1">
-          <a:blip r:embed="rId2">
-            <a:alphaModFix/>
-          </a:blip>
-          <a:srcRect t="-517"/>
-          <a:stretch/>
-        </p:blipFill>
-        <p:spPr>
-          <a:xfrm>
-            <a:off x="428172" y="2149203"/>
-            <a:ext cx="1659658" cy="1985014"/>
-          </a:xfrm>
-          <a:prstGeom prst="rect">
-            <a:avLst/>
-          </a:prstGeom>
-          <a:noFill/>
-          <a:ln>
-            <a:noFill/>
-          </a:ln>
-        </p:spPr>
-      </p:pic>
-      <p:sp>
-        <p:nvSpPr>
-          <p:cNvPr id="8" name="Segnaposto contenuto 2">
-            <a:extLst>
-              <a:ext uri="{FF2B5EF4-FFF2-40B4-BE49-F238E27FC236}">
-                <a16:creationId xmlns:a16="http://schemas.microsoft.com/office/drawing/2014/main" id="{702BA522-6E01-F8A9-9985-C031C76C2B43}"/>
-              </a:ext>
-            </a:extLst>
-          </p:cNvPr>
-          <p:cNvSpPr txBox="1">
-            <a:spLocks/>
-          </p:cNvSpPr>
-          <p:nvPr/>
-        </p:nvSpPr>
-        <p:spPr>
-          <a:xfrm>
-            <a:off x="2190045" y="2996119"/>
-            <a:ext cx="7197083" cy="3518303"/>
-          </a:xfrm>
-          <a:prstGeom prst="rect">
-            <a:avLst/>
-          </a:prstGeom>
-        </p:spPr>
-        <p:txBody>
-          <a:bodyPr vert="horz" lIns="91440" tIns="45720" rIns="91440" bIns="45720" rtlCol="0">
-            <a:normAutofit/>
-          </a:bodyPr>
-          <a:lstStyle>
-            <a:lvl1pPr marL="342900" indent="-342900" algn="l" defTabSz="914400" rtl="0" eaLnBrk="1" latinLnBrk="0" hangingPunct="1">
-              <a:lnSpc>
-                <a:spcPct val="90000"/>
-              </a:lnSpc>
-              <a:spcBef>
-                <a:spcPts val="1000"/>
-              </a:spcBef>
-              <a:buClr>
-                <a:srgbClr val="00B050"/>
-              </a:buClr>
-              <a:buFont typeface="Wingdings" panose="05000000000000000000" pitchFamily="2" charset="2"/>
-              <a:buChar char="Ø"/>
-              <a:defRPr sz="2400" kern="1200">
-                <a:solidFill>
-                  <a:schemeClr val="tx1"/>
-                </a:solidFill>
-                <a:latin typeface="Palatino Linotype" panose="02040502050505030304" pitchFamily="18" charset="0"/>
-                <a:ea typeface="+mn-ea"/>
-                <a:cs typeface="+mn-cs"/>
-              </a:defRPr>
-            </a:lvl1pPr>
-            <a:lvl2pPr marL="685800" indent="-228600" algn="l" defTabSz="914400" rtl="0" eaLnBrk="1" latinLnBrk="0" hangingPunct="1">
-              <a:lnSpc>
-                <a:spcPct val="90000"/>
-              </a:lnSpc>
-              <a:spcBef>
-                <a:spcPts val="500"/>
-              </a:spcBef>
-              <a:buClr>
-                <a:srgbClr val="00B050"/>
-              </a:buClr>
-              <a:buFont typeface="Wingdings" panose="05000000000000000000" pitchFamily="2" charset="2"/>
-              <a:buChar char="§"/>
-              <a:defRPr sz="2000" kern="1200">
-                <a:solidFill>
-                  <a:schemeClr val="tx1"/>
-                </a:solidFill>
-                <a:latin typeface="Palatino Linotype" panose="02040502050505030304" pitchFamily="18" charset="0"/>
-                <a:ea typeface="+mn-ea"/>
-                <a:cs typeface="+mn-cs"/>
-              </a:defRPr>
-            </a:lvl2pPr>
-            <a:lvl3pPr marL="1143000" indent="-228600" algn="l" defTabSz="914400" rtl="0" eaLnBrk="1" latinLnBrk="0" hangingPunct="1">
-              <a:lnSpc>
-                <a:spcPct val="90000"/>
-              </a:lnSpc>
-              <a:spcBef>
-                <a:spcPts val="500"/>
-              </a:spcBef>
-              <a:buClr>
-                <a:srgbClr val="00B050"/>
-              </a:buClr>
-              <a:buFont typeface="Arial" panose="020B0604020202020204" pitchFamily="34" charset="0"/>
-              <a:buChar char="•"/>
-              <a:defRPr sz="1800" kern="1200">
-                <a:solidFill>
-                  <a:schemeClr val="tx1"/>
-                </a:solidFill>
-                <a:latin typeface="Palatino Linotype" panose="02040502050505030304" pitchFamily="18" charset="0"/>
-                <a:ea typeface="+mn-ea"/>
-                <a:cs typeface="+mn-cs"/>
-              </a:defRPr>
-            </a:lvl3pPr>
-            <a:lvl4pPr marL="1600200" indent="-228600" algn="l" defTabSz="914400" rtl="0" eaLnBrk="1" latinLnBrk="0" hangingPunct="1">
-              <a:lnSpc>
-                <a:spcPct val="90000"/>
-              </a:lnSpc>
-              <a:spcBef>
-                <a:spcPts val="500"/>
-              </a:spcBef>
-              <a:buClr>
-                <a:srgbClr val="00B050"/>
-              </a:buClr>
-              <a:buFont typeface="Courier New" panose="02070309020205020404" pitchFamily="49" charset="0"/>
-              <a:buChar char="o"/>
-              <a:defRPr sz="1600" kern="1200">
-                <a:solidFill>
-                  <a:schemeClr val="tx1"/>
-                </a:solidFill>
-                <a:latin typeface="Palatino Linotype" panose="02040502050505030304" pitchFamily="18" charset="0"/>
-                <a:ea typeface="+mn-ea"/>
-                <a:cs typeface="+mn-cs"/>
-              </a:defRPr>
-            </a:lvl4pPr>
-            <a:lvl5pPr marL="2057400" indent="-228600" algn="l" defTabSz="914400" rtl="0" eaLnBrk="1" latinLnBrk="0" hangingPunct="1">
-              <a:lnSpc>
-                <a:spcPct val="90000"/>
-              </a:lnSpc>
-              <a:spcBef>
-                <a:spcPts val="500"/>
-              </a:spcBef>
-              <a:buClr>
-                <a:srgbClr val="00B050"/>
-              </a:buClr>
-              <a:buFont typeface="Times New Roman" panose="02020603050405020304" pitchFamily="18" charset="0"/>
-              <a:buChar char="̶"/>
-              <a:defRPr sz="1600" kern="1200">
-                <a:solidFill>
-                  <a:schemeClr val="tx1"/>
-                </a:solidFill>
-                <a:latin typeface="Palatino Linotype" panose="02040502050505030304" pitchFamily="18" charset="0"/>
-                <a:ea typeface="+mn-ea"/>
-                <a:cs typeface="+mn-cs"/>
-              </a:defRPr>
-            </a:lvl5pPr>
-            <a:lvl6pPr marL="2514600" indent="-228600" algn="l" defTabSz="914400" rtl="0" eaLnBrk="1" latinLnBrk="0" hangingPunct="1">
-              <a:lnSpc>
-                <a:spcPct val="90000"/>
-              </a:lnSpc>
-              <a:spcBef>
-                <a:spcPts val="500"/>
-              </a:spcBef>
-              <a:buFont typeface="Arial" panose="020B0604020202020204" pitchFamily="34" charset="0"/>
-              <a:buChar char="•"/>
-              <a:defRPr sz="1800" kern="1200">
-                <a:solidFill>
-                  <a:schemeClr val="tx1"/>
-                </a:solidFill>
-                <a:latin typeface="+mn-lt"/>
-                <a:ea typeface="+mn-ea"/>
-                <a:cs typeface="+mn-cs"/>
-              </a:defRPr>
-            </a:lvl6pPr>
-            <a:lvl7pPr marL="2971800" indent="-228600" algn="l" defTabSz="914400" rtl="0" eaLnBrk="1" latinLnBrk="0" hangingPunct="1">
-              <a:lnSpc>
-                <a:spcPct val="90000"/>
-              </a:lnSpc>
-              <a:spcBef>
-                <a:spcPts val="500"/>
-              </a:spcBef>
-              <a:buFont typeface="Arial" panose="020B0604020202020204" pitchFamily="34" charset="0"/>
-              <a:buChar char="•"/>
-              <a:defRPr sz="1800" kern="1200">
-                <a:solidFill>
-                  <a:schemeClr val="tx1"/>
-                </a:solidFill>
-                <a:latin typeface="+mn-lt"/>
-                <a:ea typeface="+mn-ea"/>
-                <a:cs typeface="+mn-cs"/>
-              </a:defRPr>
-            </a:lvl7pPr>
-            <a:lvl8pPr marL="3429000" indent="-228600" algn="l" defTabSz="914400" rtl="0" eaLnBrk="1" latinLnBrk="0" hangingPunct="1">
-              <a:lnSpc>
-                <a:spcPct val="90000"/>
-              </a:lnSpc>
-              <a:spcBef>
-                <a:spcPts val="500"/>
-              </a:spcBef>
-              <a:buFont typeface="Arial" panose="020B0604020202020204" pitchFamily="34" charset="0"/>
-              <a:buChar char="•"/>
-              <a:defRPr sz="1800" kern="1200">
-                <a:solidFill>
-                  <a:schemeClr val="tx1"/>
-                </a:solidFill>
-                <a:latin typeface="+mn-lt"/>
-                <a:ea typeface="+mn-ea"/>
-                <a:cs typeface="+mn-cs"/>
-              </a:defRPr>
-            </a:lvl8pPr>
-            <a:lvl9pPr marL="3886200" indent="-228600" algn="l" defTabSz="914400" rtl="0" eaLnBrk="1" latinLnBrk="0" hangingPunct="1">
-              <a:lnSpc>
-                <a:spcPct val="90000"/>
-              </a:lnSpc>
-              <a:spcBef>
-                <a:spcPts val="500"/>
-              </a:spcBef>
-              <a:buFont typeface="Arial" panose="020B0604020202020204" pitchFamily="34" charset="0"/>
-              <a:buChar char="•"/>
-              <a:defRPr sz="1800" kern="1200">
-                <a:solidFill>
-                  <a:schemeClr val="tx1"/>
-                </a:solidFill>
-                <a:latin typeface="+mn-lt"/>
-                <a:ea typeface="+mn-ea"/>
-                <a:cs typeface="+mn-cs"/>
-              </a:defRPr>
-            </a:lvl9pPr>
-          </a:lstStyle>
-          <a:p>
-            <a:r>
-              <a:rPr lang="en-US" sz="1800" dirty="0">
-                <a:latin typeface="Aptos" panose="020B0004020202020204" pitchFamily="34" charset="0"/>
-              </a:rPr>
-              <a:t>Luca Cossu</a:t>
-            </a:r>
-          </a:p>
-          <a:p>
-            <a:pPr marL="0" indent="0">
-              <a:buNone/>
-            </a:pPr>
-            <a:r>
-              <a:rPr lang="en-US" sz="1800" dirty="0">
-                <a:solidFill>
-                  <a:srgbClr val="C00000"/>
-                </a:solidFill>
-                <a:latin typeface="Aptos" panose="020B0004020202020204" pitchFamily="34" charset="0"/>
-                <a:hlinkClick r:id="rId3">
-                  <a:extLst>
-                    <a:ext uri="{A12FA001-AC4F-418D-AE19-62706E023703}">
-                      <ahyp:hlinkClr xmlns:ahyp="http://schemas.microsoft.com/office/drawing/2018/hyperlinkcolor" val="tx"/>
-                    </a:ext>
-                  </a:extLst>
-                </a:hlinkClick>
-              </a:rPr>
-              <a:t>luca.cossu@phd.unipd.it</a:t>
-            </a:r>
-            <a:r>
-              <a:rPr lang="en-US" sz="1800" dirty="0">
-                <a:solidFill>
-                  <a:srgbClr val="C00000"/>
-                </a:solidFill>
-                <a:latin typeface="Aptos" panose="020B0004020202020204" pitchFamily="34" charset="0"/>
-              </a:rPr>
-              <a:t> </a:t>
-            </a:r>
-          </a:p>
-          <a:p>
-            <a:endParaRPr lang="en-US" sz="1800" dirty="0">
-              <a:latin typeface="Aptos" panose="020B0004020202020204" pitchFamily="34" charset="0"/>
-            </a:endParaRPr>
-          </a:p>
-          <a:p>
-            <a:endParaRPr lang="en-US" sz="1800" dirty="0">
-              <a:latin typeface="Aptos" panose="020B0004020202020204" pitchFamily="34" charset="0"/>
-            </a:endParaRPr>
-          </a:p>
-          <a:p>
-            <a:endParaRPr lang="en-US" sz="1800" dirty="0">
-              <a:latin typeface="Aptos" panose="020B0004020202020204" pitchFamily="34" charset="0"/>
-            </a:endParaRPr>
-          </a:p>
-          <a:p>
-            <a:r>
-              <a:rPr lang="en-US" sz="1800" dirty="0">
-                <a:latin typeface="Aptos" panose="020B0004020202020204" pitchFamily="34" charset="0"/>
-              </a:rPr>
-              <a:t>Alberto </a:t>
-            </a:r>
-            <a:r>
-              <a:rPr lang="en-US" sz="1800" dirty="0" err="1">
-                <a:latin typeface="Aptos" panose="020B0004020202020204" pitchFamily="34" charset="0"/>
-              </a:rPr>
-              <a:t>Gastaldello</a:t>
-            </a:r>
-            <a:endParaRPr lang="en-US" sz="1800" dirty="0">
-              <a:solidFill>
-                <a:srgbClr val="C00000"/>
-              </a:solidFill>
-              <a:latin typeface="Aptos" panose="020B0004020202020204" pitchFamily="34" charset="0"/>
-            </a:endParaRPr>
-          </a:p>
-          <a:p>
-            <a:pPr marL="0" indent="0">
-              <a:buNone/>
-            </a:pPr>
-            <a:r>
-              <a:rPr lang="en-US" sz="1800" dirty="0">
-                <a:solidFill>
-                  <a:srgbClr val="C00000"/>
-                </a:solidFill>
-                <a:latin typeface="Aptos" panose="020B0004020202020204" pitchFamily="34" charset="0"/>
-                <a:hlinkClick r:id="rId4">
-                  <a:extLst>
-                    <a:ext uri="{A12FA001-AC4F-418D-AE19-62706E023703}">
-                      <ahyp:hlinkClr xmlns:ahyp="http://schemas.microsoft.com/office/drawing/2018/hyperlinkcolor" val="tx"/>
-                    </a:ext>
-                  </a:extLst>
-                </a:hlinkClick>
-              </a:rPr>
-              <a:t>alberto.gastaldello.2@phd.unipd.it</a:t>
-            </a:r>
-            <a:r>
-              <a:rPr lang="en-US" sz="1800" dirty="0">
-                <a:solidFill>
-                  <a:srgbClr val="C00000"/>
-                </a:solidFill>
-                <a:latin typeface="Aptos" panose="020B0004020202020204" pitchFamily="34" charset="0"/>
-              </a:rPr>
-              <a:t> </a:t>
-            </a:r>
-            <a:br>
-              <a:rPr lang="en-US" sz="1800" dirty="0">
-                <a:latin typeface="Aptos" panose="020B0004020202020204" pitchFamily="34" charset="0"/>
-              </a:rPr>
-            </a:br>
-            <a:endParaRPr lang="en-US" sz="1800" dirty="0">
-              <a:latin typeface="Aptos" panose="020B0004020202020204" pitchFamily="34" charset="0"/>
-            </a:endParaRPr>
-          </a:p>
-          <a:p>
-            <a:endParaRPr lang="en-US" sz="1800" dirty="0">
-              <a:latin typeface="Aptos" panose="020B0004020202020204" pitchFamily="34" charset="0"/>
-            </a:endParaRPr>
-          </a:p>
-          <a:p>
-            <a:endParaRPr lang="en-US" sz="1800" dirty="0">
-              <a:latin typeface="Aptos" panose="020B0004020202020204" pitchFamily="34" charset="0"/>
-            </a:endParaRPr>
-          </a:p>
-        </p:txBody>
-      </p:sp>
-      <p:pic>
-        <p:nvPicPr>
-          <p:cNvPr id="13" name="Picture 12" descr="A person wearing glasses and a blue jacket&#10;&#10;AI-generated content may be incorrect.">
-            <a:extLst>
-              <a:ext uri="{FF2B5EF4-FFF2-40B4-BE49-F238E27FC236}">
-                <a16:creationId xmlns:a16="http://schemas.microsoft.com/office/drawing/2014/main" id="{988E4DF5-823B-DB3E-BE13-A68FBC5CC80A}"/>
-              </a:ext>
-            </a:extLst>
-          </p:cNvPr>
-          <p:cNvPicPr>
-            <a:picLocks noChangeAspect="1"/>
-          </p:cNvPicPr>
-          <p:nvPr/>
-        </p:nvPicPr>
-        <p:blipFill>
-          <a:blip r:embed="rId5">
-            <a:extLst>
-              <a:ext uri="{28A0092B-C50C-407E-A947-70E740481C1C}">
-                <a14:useLocalDpi xmlns:a14="http://schemas.microsoft.com/office/drawing/2010/main" val="0"/>
-              </a:ext>
-            </a:extLst>
-          </a:blip>
-          <a:srcRect l="20234" t="7515" r="17055" b="32838"/>
-          <a:stretch/>
-        </p:blipFill>
-        <p:spPr>
-          <a:xfrm>
-            <a:off x="428169" y="4347633"/>
-            <a:ext cx="1663677" cy="1656714"/>
-          </a:xfrm>
-          <a:prstGeom prst="rect">
-            <a:avLst/>
-          </a:prstGeom>
-        </p:spPr>
-      </p:pic>
-      <p:pic>
-        <p:nvPicPr>
-          <p:cNvPr id="9" name="Picture 8" descr="A table with text on it&#10;&#10;AI-generated content may be incorrect.">
-            <a:extLst>
-              <a:ext uri="{FF2B5EF4-FFF2-40B4-BE49-F238E27FC236}">
-                <a16:creationId xmlns:a16="http://schemas.microsoft.com/office/drawing/2014/main" id="{7447DC5E-6376-B627-E750-1F8578585271}"/>
-              </a:ext>
-            </a:extLst>
-          </p:cNvPr>
-          <p:cNvPicPr>
-            <a:picLocks noChangeAspect="1"/>
-          </p:cNvPicPr>
-          <p:nvPr/>
-        </p:nvPicPr>
-        <p:blipFill>
-          <a:blip r:embed="rId6">
-            <a:extLst>
-              <a:ext uri="{28A0092B-C50C-407E-A947-70E740481C1C}">
-                <a14:useLocalDpi xmlns:a14="http://schemas.microsoft.com/office/drawing/2010/main" val="0"/>
-              </a:ext>
-            </a:extLst>
-          </a:blip>
-          <a:stretch>
-            <a:fillRect/>
-          </a:stretch>
-        </p:blipFill>
-        <p:spPr>
-          <a:xfrm>
-            <a:off x="5599127" y="2631395"/>
-            <a:ext cx="6346438" cy="1989364"/>
-          </a:xfrm>
-          <a:prstGeom prst="rect">
-            <a:avLst/>
-          </a:prstGeom>
-        </p:spPr>
-      </p:pic>
-    </p:spTree>
-    <p:extLst>
-      <p:ext uri="{BB962C8B-B14F-4D97-AF65-F5344CB8AC3E}">
-        <p14:creationId xmlns:p14="http://schemas.microsoft.com/office/powerpoint/2010/main" val="3733545451"/>
-      </p:ext>
-    </p:extLst>
-  </p:cSld>
-  <p:clrMapOvr>
-    <a:masterClrMapping/>
-  </p:clrMapOvr>
-</p:sld>
-</file>
-
-<file path=ppt/slides/slide41.xml><?xml version="1.0" encoding="utf-8"?>
-<p:sld xmlns:a="http://schemas.openxmlformats.org/drawingml/2006/main" xmlns:r="http://schemas.openxmlformats.org/officeDocument/2006/relationships" xmlns:p="http://schemas.openxmlformats.org/presentationml/2006/main">
-  <p:cSld>
-    <p:spTree>
-      <p:nvGrpSpPr>
-        <p:cNvPr id="1" name=""/>
-        <p:cNvGrpSpPr/>
-        <p:nvPr/>
-      </p:nvGrpSpPr>
-      <p:grpSpPr>
-        <a:xfrm>
-          <a:off x="0" y="0"/>
-          <a:ext cx="0" cy="0"/>
-          <a:chOff x="0" y="0"/>
-          <a:chExt cx="0" cy="0"/>
-        </a:xfrm>
-      </p:grpSpPr>
-      <p:sp>
-        <p:nvSpPr>
-          <p:cNvPr id="2" name="Titolo 1"/>
-          <p:cNvSpPr>
-            <a:spLocks noGrp="1"/>
-          </p:cNvSpPr>
-          <p:nvPr>
-            <p:ph type="title"/>
-          </p:nvPr>
-        </p:nvSpPr>
-        <p:spPr/>
-        <p:txBody>
-          <a:bodyPr/>
-          <a:lstStyle/>
-          <a:p>
-            <a:r>
-              <a:rPr lang="it-IT" dirty="0" err="1"/>
-              <a:t>Discord</a:t>
-            </a:r>
-            <a:r>
-              <a:rPr lang="it-IT" dirty="0"/>
-              <a:t> server</a:t>
-            </a:r>
-            <a:endParaRPr lang="en-GB" dirty="0"/>
-          </a:p>
-        </p:txBody>
-      </p:sp>
-      <p:sp>
-        <p:nvSpPr>
-          <p:cNvPr id="3" name="Segnaposto contenuto 2"/>
-          <p:cNvSpPr>
-            <a:spLocks noGrp="1"/>
-          </p:cNvSpPr>
-          <p:nvPr>
-            <p:ph idx="1"/>
-          </p:nvPr>
-        </p:nvSpPr>
-        <p:spPr>
-          <a:xfrm>
-            <a:off x="428172" y="4078014"/>
-            <a:ext cx="11368314" cy="2525986"/>
-          </a:xfrm>
-        </p:spPr>
-        <p:txBody>
-          <a:bodyPr>
-            <a:normAutofit/>
-          </a:bodyPr>
-          <a:lstStyle/>
-          <a:p>
-            <a:r>
-              <a:rPr lang="en-US" dirty="0"/>
-              <a:t>Join the Discord server to get in touch and ask questions</a:t>
-            </a:r>
-          </a:p>
-          <a:p>
-            <a:endParaRPr lang="en-US" dirty="0"/>
-          </a:p>
-          <a:p>
-            <a:r>
-              <a:rPr lang="en-US" b="1" dirty="0"/>
-              <a:t>Link: </a:t>
-            </a:r>
-            <a:r>
-              <a:rPr lang="en-US" b="1" dirty="0">
-                <a:solidFill>
-                  <a:srgbClr val="C00000"/>
-                </a:solidFill>
-              </a:rPr>
-              <a:t>https://</a:t>
-            </a:r>
-            <a:r>
-              <a:rPr lang="en-US" b="1" dirty="0" err="1">
-                <a:solidFill>
-                  <a:srgbClr val="C00000"/>
-                </a:solidFill>
-              </a:rPr>
-              <a:t>discord.gg</a:t>
-            </a:r>
-            <a:r>
-              <a:rPr lang="en-US" b="1" dirty="0">
-                <a:solidFill>
-                  <a:srgbClr val="C00000"/>
-                </a:solidFill>
-              </a:rPr>
-              <a:t>/j76A3D27bm</a:t>
-            </a:r>
-          </a:p>
-        </p:txBody>
-      </p:sp>
-      <p:sp>
-        <p:nvSpPr>
-          <p:cNvPr id="6" name="Segnaposto numero diapositiva 5"/>
-          <p:cNvSpPr>
-            <a:spLocks noGrp="1"/>
-          </p:cNvSpPr>
-          <p:nvPr>
-            <p:ph type="sldNum" sz="quarter" idx="12"/>
-          </p:nvPr>
-        </p:nvSpPr>
-        <p:spPr/>
-        <p:txBody>
-          <a:bodyPr/>
-          <a:lstStyle/>
-          <a:p>
-            <a:fld id="{31DE2C5B-556E-47B8-A792-024C2FCA4ACC}" type="slidenum">
-              <a:rPr lang="en-GB" smtClean="0"/>
-              <a:t>41</a:t>
             </a:fld>
             <a:endParaRPr lang="en-GB"/>
           </a:p>
@@ -22217,7 +21441,7 @@
 </p:sld>
 </file>
 
-<file path=ppt/slides/slide42.xml><?xml version="1.0" encoding="utf-8"?>
+<file path=ppt/slides/slide41.xml><?xml version="1.0" encoding="utf-8"?>
 <p:sld xmlns:a="http://schemas.openxmlformats.org/drawingml/2006/main" xmlns:r="http://schemas.openxmlformats.org/officeDocument/2006/relationships" xmlns:p="http://schemas.openxmlformats.org/presentationml/2006/main">
   <p:cSld>
     <p:spTree>
@@ -22290,7 +21514,7 @@
           <a:p>
             <a:fld id="{31DE2C5B-556E-47B8-A792-024C2FCA4ACC}" type="slidenum">
               <a:rPr lang="en-GB" smtClean="0"/>
-              <a:t>42</a:t>
+              <a:t>41</a:t>
             </a:fld>
             <a:endParaRPr lang="en-GB"/>
           </a:p>
@@ -22309,7 +21533,7 @@
 </p:sld>
 </file>
 
-<file path=ppt/slides/slide43.xml><?xml version="1.0" encoding="utf-8"?>
+<file path=ppt/slides/slide42.xml><?xml version="1.0" encoding="utf-8"?>
 <p:sld xmlns:a="http://schemas.openxmlformats.org/drawingml/2006/main" xmlns:r="http://schemas.openxmlformats.org/officeDocument/2006/relationships" xmlns:p="http://schemas.openxmlformats.org/presentationml/2006/main">
   <p:cSld>
     <p:spTree>
@@ -22446,7 +21670,7 @@
           <a:p>
             <a:fld id="{31DE2C5B-556E-47B8-A792-024C2FCA4ACC}" type="slidenum">
               <a:rPr lang="en-GB" smtClean="0"/>
-              <a:t>43</a:t>
+              <a:t>42</a:t>
             </a:fld>
             <a:endParaRPr lang="en-GB" dirty="0"/>
           </a:p>
@@ -22801,7 +22025,7 @@
 </p:sld>
 </file>
 
-<file path=ppt/slides/slide44.xml><?xml version="1.0" encoding="utf-8"?>
+<file path=ppt/slides/slide43.xml><?xml version="1.0" encoding="utf-8"?>
 <p:sld xmlns:a="http://schemas.openxmlformats.org/drawingml/2006/main" xmlns:r="http://schemas.openxmlformats.org/officeDocument/2006/relationships" xmlns:p="http://schemas.openxmlformats.org/presentationml/2006/main">
   <p:cSld>
     <p:spTree>
@@ -22949,7 +22173,7 @@
           <a:p>
             <a:fld id="{31DE2C5B-556E-47B8-A792-024C2FCA4ACC}" type="slidenum">
               <a:rPr lang="en-GB" smtClean="0"/>
-              <a:t>44</a:t>
+              <a:t>43</a:t>
             </a:fld>
             <a:endParaRPr lang="en-GB" dirty="0"/>
           </a:p>
@@ -23311,7 +22535,7 @@
 </p:sld>
 </file>
 
-<file path=ppt/slides/slide45.xml><?xml version="1.0" encoding="utf-8"?>
+<file path=ppt/slides/slide44.xml><?xml version="1.0" encoding="utf-8"?>
 <p:sld xmlns:a="http://schemas.openxmlformats.org/drawingml/2006/main" xmlns:r="http://schemas.openxmlformats.org/officeDocument/2006/relationships" xmlns:p="http://schemas.openxmlformats.org/presentationml/2006/main">
   <p:cSld>
     <p:spTree>
@@ -23480,7 +22704,7 @@
           <a:p>
             <a:fld id="{31DE2C5B-556E-47B8-A792-024C2FCA4ACC}" type="slidenum">
               <a:rPr lang="en-GB" smtClean="0"/>
-              <a:t>45</a:t>
+              <a:t>44</a:t>
             </a:fld>
             <a:endParaRPr lang="en-GB" dirty="0"/>
           </a:p>
@@ -23840,7 +23064,7 @@
 </p:sld>
 </file>
 
-<file path=ppt/slides/slide46.xml><?xml version="1.0" encoding="utf-8"?>
+<file path=ppt/slides/slide45.xml><?xml version="1.0" encoding="utf-8"?>
 <p:sld xmlns:a="http://schemas.openxmlformats.org/drawingml/2006/main" xmlns:r="http://schemas.openxmlformats.org/officeDocument/2006/relationships" xmlns:p="http://schemas.openxmlformats.org/presentationml/2006/main">
   <p:cSld>
     <p:spTree>
@@ -24010,7 +23234,7 @@
           <a:p>
             <a:fld id="{31DE2C5B-556E-47B8-A792-024C2FCA4ACC}" type="slidenum">
               <a:rPr lang="en-GB" smtClean="0"/>
-              <a:t>46</a:t>
+              <a:t>45</a:t>
             </a:fld>
             <a:endParaRPr lang="en-GB" dirty="0"/>
           </a:p>
@@ -24449,7 +23673,7 @@
 </p:sld>
 </file>
 
-<file path=ppt/slides/slide47.xml><?xml version="1.0" encoding="utf-8"?>
+<file path=ppt/slides/slide46.xml><?xml version="1.0" encoding="utf-8"?>
 <p:sld xmlns:a="http://schemas.openxmlformats.org/drawingml/2006/main" xmlns:r="http://schemas.openxmlformats.org/officeDocument/2006/relationships" xmlns:p="http://schemas.openxmlformats.org/presentationml/2006/main">
   <p:cSld>
     <p:spTree>
@@ -24612,7 +23836,7 @@
           <a:p>
             <a:fld id="{31DE2C5B-556E-47B8-A792-024C2FCA4ACC}" type="slidenum">
               <a:rPr lang="en-GB" smtClean="0"/>
-              <a:t>47</a:t>
+              <a:t>46</a:t>
             </a:fld>
             <a:endParaRPr lang="en-GB" dirty="0"/>
           </a:p>
@@ -24705,7 +23929,7 @@
 </p:sld>
 </file>
 
-<file path=ppt/slides/slide48.xml><?xml version="1.0" encoding="utf-8"?>
+<file path=ppt/slides/slide47.xml><?xml version="1.0" encoding="utf-8"?>
 <p:sld xmlns:a="http://schemas.openxmlformats.org/drawingml/2006/main" xmlns:r="http://schemas.openxmlformats.org/officeDocument/2006/relationships" xmlns:p="http://schemas.openxmlformats.org/presentationml/2006/main">
   <p:cSld>
     <p:spTree>
@@ -24959,7 +24183,7 @@
           <a:p>
             <a:fld id="{31DE2C5B-556E-47B8-A792-024C2FCA4ACC}" type="slidenum">
               <a:rPr lang="en-GB" smtClean="0"/>
-              <a:t>48</a:t>
+              <a:t>47</a:t>
             </a:fld>
             <a:endParaRPr lang="en-GB" dirty="0"/>
           </a:p>
@@ -26369,7 +25593,7 @@
 </p:sld>
 </file>
 
-<file path=ppt/slides/slide49.xml><?xml version="1.0" encoding="utf-8"?>
+<file path=ppt/slides/slide48.xml><?xml version="1.0" encoding="utf-8"?>
 <p:sld xmlns:a="http://schemas.openxmlformats.org/drawingml/2006/main" xmlns:r="http://schemas.openxmlformats.org/officeDocument/2006/relationships" xmlns:p="http://schemas.openxmlformats.org/presentationml/2006/main">
   <p:cSld>
     <p:spTree>
@@ -26603,7 +25827,7 @@
           <a:p>
             <a:fld id="{31DE2C5B-556E-47B8-A792-024C2FCA4ACC}" type="slidenum">
               <a:rPr lang="en-GB" smtClean="0"/>
-              <a:t>49</a:t>
+              <a:t>48</a:t>
             </a:fld>
             <a:endParaRPr lang="en-GB" dirty="0"/>
           </a:p>

</xml_diff>